<commit_message>
ios Bilder, QR-Code Update
</commit_message>
<xml_diff>
--- a/presentation/PosterSS2025_MobileGIS_final_G3.pptx
+++ b/presentation/PosterSS2025_MobileGIS_final_G3.pptx
@@ -6,14 +6,16 @@
     <p:sldMasterId id="2147483660" r:id="rId2"/>
   </p:sldMasterIdLst>
   <p:notesMasterIdLst>
-    <p:notesMasterId r:id="rId5"/>
+    <p:notesMasterId r:id="rId7"/>
   </p:notesMasterIdLst>
   <p:handoutMasterIdLst>
-    <p:handoutMasterId r:id="rId6"/>
+    <p:handoutMasterId r:id="rId8"/>
   </p:handoutMasterIdLst>
   <p:sldIdLst>
     <p:sldId id="261" r:id="rId3"/>
-    <p:sldId id="260" r:id="rId4"/>
+    <p:sldId id="263" r:id="rId4"/>
+    <p:sldId id="262" r:id="rId5"/>
+    <p:sldId id="260" r:id="rId6"/>
   </p:sldIdLst>
   <p:sldSz cx="6858000" cy="9906000" type="A4"/>
   <p:notesSz cx="7104063" cy="10234613"/>
@@ -167,6 +169,9 @@
         </p15:guide>
       </p15:sldGuideLst>
     </p:ext>
+    <p:ext uri="{2D200454-40CA-4A62-9FC3-DE9A4176ACB9}">
+      <p15:notesGuideLst xmlns:p15="http://schemas.microsoft.com/office/powerpoint/2012/main"/>
+    </p:ext>
   </p:extLst>
 </p:presentation>
 </file>
@@ -265,7 +270,7 @@
           <a:p>
             <a:fld id="{5ADFE7E4-19D8-40FC-8A90-AA6A5944CDAD}" type="datetimeFigureOut">
               <a:rPr lang="en-GB" smtClean="0"/>
-              <a:t>19/07/2025</a:t>
+              <a:t>24/07/2025</a:t>
             </a:fld>
             <a:endParaRPr lang="en-GB"/>
           </a:p>
@@ -3900,6 +3905,114 @@
       </p:grpSpPr>
       <p:sp>
         <p:nvSpPr>
+          <p:cNvPr id="24" name="Rechteck: eine Ecke abgerundet 23">
+            <a:extLst>
+              <a:ext uri="{FF2B5EF4-FFF2-40B4-BE49-F238E27FC236}">
+                <a16:creationId xmlns:a16="http://schemas.microsoft.com/office/drawing/2014/main" id="{CD4C7D39-1B6D-9C80-50D0-CB3483C511A9}"/>
+              </a:ext>
+            </a:extLst>
+          </p:cNvPr>
+          <p:cNvSpPr/>
+          <p:nvPr/>
+        </p:nvSpPr>
+        <p:spPr>
+          <a:xfrm flipH="1">
+            <a:off x="1850388" y="9278006"/>
+            <a:ext cx="5007609" cy="627993"/>
+          </a:xfrm>
+          <a:prstGeom prst="round1Rect">
+            <a:avLst>
+              <a:gd name="adj" fmla="val 50000"/>
+            </a:avLst>
+          </a:prstGeom>
+          <a:solidFill>
+            <a:srgbClr val="4664AA"/>
+          </a:solidFill>
+          <a:ln>
+            <a:noFill/>
+          </a:ln>
+        </p:spPr>
+        <p:style>
+          <a:lnRef idx="2">
+            <a:schemeClr val="accent1">
+              <a:shade val="15000"/>
+            </a:schemeClr>
+          </a:lnRef>
+          <a:fillRef idx="1">
+            <a:schemeClr val="accent1"/>
+          </a:fillRef>
+          <a:effectRef idx="0">
+            <a:schemeClr val="accent1"/>
+          </a:effectRef>
+          <a:fontRef idx="minor">
+            <a:schemeClr val="lt1"/>
+          </a:fontRef>
+        </p:style>
+        <p:txBody>
+          <a:bodyPr rtlCol="0" anchor="ctr"/>
+          <a:lstStyle/>
+          <a:p>
+            <a:pPr algn="ctr"/>
+            <a:endParaRPr lang="en-GB"/>
+          </a:p>
+        </p:txBody>
+      </p:sp>
+      <p:sp>
+        <p:nvSpPr>
+          <p:cNvPr id="23" name="Rechteck: eine Ecke abgerundet 22">
+            <a:extLst>
+              <a:ext uri="{FF2B5EF4-FFF2-40B4-BE49-F238E27FC236}">
+                <a16:creationId xmlns:a16="http://schemas.microsoft.com/office/drawing/2014/main" id="{1121F5E7-32F0-57ED-F059-75B3A3651AEE}"/>
+              </a:ext>
+            </a:extLst>
+          </p:cNvPr>
+          <p:cNvSpPr/>
+          <p:nvPr/>
+        </p:nvSpPr>
+        <p:spPr>
+          <a:xfrm flipV="1">
+            <a:off x="0" y="-2"/>
+            <a:ext cx="4701540" cy="1260019"/>
+          </a:xfrm>
+          <a:prstGeom prst="round1Rect">
+            <a:avLst>
+              <a:gd name="adj" fmla="val 42873"/>
+            </a:avLst>
+          </a:prstGeom>
+          <a:solidFill>
+            <a:srgbClr val="4664AA"/>
+          </a:solidFill>
+          <a:ln>
+            <a:noFill/>
+          </a:ln>
+        </p:spPr>
+        <p:style>
+          <a:lnRef idx="2">
+            <a:schemeClr val="accent1">
+              <a:shade val="15000"/>
+            </a:schemeClr>
+          </a:lnRef>
+          <a:fillRef idx="1">
+            <a:schemeClr val="accent1"/>
+          </a:fillRef>
+          <a:effectRef idx="0">
+            <a:schemeClr val="accent1"/>
+          </a:effectRef>
+          <a:fontRef idx="minor">
+            <a:schemeClr val="lt1"/>
+          </a:fontRef>
+        </p:style>
+        <p:txBody>
+          <a:bodyPr rtlCol="0" anchor="ctr"/>
+          <a:lstStyle/>
+          <a:p>
+            <a:pPr algn="ctr"/>
+            <a:endParaRPr lang="en-GB"/>
+          </a:p>
+        </p:txBody>
+      </p:sp>
+      <p:sp>
+        <p:nvSpPr>
           <p:cNvPr id="4" name="Textfeld 3">
             <a:extLst>
               <a:ext uri="{FF2B5EF4-FFF2-40B4-BE49-F238E27FC236}">
@@ -3927,24 +4040,112 @@
           <a:lstStyle/>
           <a:p>
             <a:r>
-              <a:rPr lang="en-US" sz="3600" noProof="0" dirty="0"/>
+              <a:rPr lang="en-US" sz="3600" noProof="0" dirty="0">
+                <a:solidFill>
+                  <a:schemeClr val="bg1"/>
+                </a:solidFill>
+              </a:rPr>
               <a:t>Explore KIT Campus</a:t>
             </a:r>
           </a:p>
           <a:p>
             <a:r>
-              <a:rPr lang="en-US" sz="2400" noProof="0" dirty="0"/>
+              <a:rPr lang="en-US" sz="2400" noProof="0" dirty="0">
+                <a:solidFill>
+                  <a:schemeClr val="bg1"/>
+                </a:solidFill>
+              </a:rPr>
               <a:t>Discover, Navigate, Enjoy.</a:t>
             </a:r>
+          </a:p>
+        </p:txBody>
+      </p:sp>
+      <p:sp>
+        <p:nvSpPr>
+          <p:cNvPr id="12" name="Textfeld 11">
+            <a:extLst>
+              <a:ext uri="{FF2B5EF4-FFF2-40B4-BE49-F238E27FC236}">
+                <a16:creationId xmlns:a16="http://schemas.microsoft.com/office/drawing/2014/main" id="{27BD1FBA-FEA5-86C7-A7D4-727019A5298C}"/>
+              </a:ext>
+            </a:extLst>
+          </p:cNvPr>
+          <p:cNvSpPr txBox="1"/>
+          <p:nvPr/>
+        </p:nvSpPr>
+        <p:spPr>
+          <a:xfrm>
+            <a:off x="1850389" y="9358197"/>
+            <a:ext cx="4900485" cy="461665"/>
+          </a:xfrm>
+          <a:prstGeom prst="rect">
+            <a:avLst/>
+          </a:prstGeom>
+          <a:noFill/>
+        </p:spPr>
+        <p:txBody>
+          <a:bodyPr wrap="square" rtlCol="0">
+            <a:spAutoFit/>
+          </a:bodyPr>
+          <a:lstStyle/>
+          <a:p>
+            <a:pPr algn="r"/>
+            <a:r>
+              <a:rPr lang="en-US" sz="1200" noProof="0" dirty="0">
+                <a:solidFill>
+                  <a:schemeClr val="bg1"/>
+                </a:solidFill>
+              </a:rPr>
+              <a:t>Korvin Brecht – Jasmin </a:t>
+            </a:r>
+            <a:r>
+              <a:rPr lang="en-US" sz="1200" noProof="0" dirty="0" err="1">
+                <a:solidFill>
+                  <a:schemeClr val="bg1"/>
+                </a:solidFill>
+              </a:rPr>
+              <a:t>Jährling</a:t>
+            </a:r>
+            <a:r>
+              <a:rPr lang="en-US" sz="1200" noProof="0" dirty="0">
+                <a:solidFill>
+                  <a:schemeClr val="bg1"/>
+                </a:solidFill>
+              </a:rPr>
+              <a:t> – Elisabeth Kral – Merlin Pillich</a:t>
+            </a:r>
+          </a:p>
+          <a:p>
+            <a:pPr algn="r"/>
+            <a:r>
+              <a:rPr lang="en-US" sz="1200" noProof="0" dirty="0">
+                <a:solidFill>
+                  <a:schemeClr val="bg1"/>
+                </a:solidFill>
+              </a:rPr>
+              <a:t>Mobile GIS – Summer Semester 2025 </a:t>
+            </a:r>
+            <a:r>
+              <a:rPr lang="en-US" sz="1200" dirty="0">
+                <a:solidFill>
+                  <a:schemeClr val="bg1"/>
+                </a:solidFill>
+              </a:rPr>
+              <a:t>– Dr.-Ing. Paul Vincent Kuper</a:t>
+            </a:r>
+            <a:endParaRPr lang="en-US" sz="1200" noProof="0" dirty="0">
+              <a:solidFill>
+                <a:schemeClr val="bg1"/>
+              </a:solidFill>
+            </a:endParaRPr>
           </a:p>
         </p:txBody>
       </p:sp>
       <p:pic>
         <p:nvPicPr>
-          <p:cNvPr id="7" name="Grafik 6" descr="Ein Bild, das Text, Screenshot, Diagramm, Zahl enthält.&#10;&#10;KI-generierte Inhalte können fehlerhaft sein.">
+          <p:cNvPr id="14" name="Grafik 13" descr="Ein Bild, das Grafiken, Screenshot, Grafikdesign, Farbigkeit enthält.&#10;&#10;KI-generierte Inhalte können fehlerhaft sein.">
             <a:extLst>
               <a:ext uri="{FF2B5EF4-FFF2-40B4-BE49-F238E27FC236}">
-                <a16:creationId xmlns:a16="http://schemas.microsoft.com/office/drawing/2014/main" id="{0886EDEE-7AA8-E7F7-2EB8-BF5B6BB90AE7}"/>
+                <a16:creationId xmlns:a16="http://schemas.microsoft.com/office/drawing/2014/main" id="{3BDF71EC-75B6-67C1-DC68-CC92E36163FD}"/>
               </a:ext>
             </a:extLst>
           </p:cNvPr>
@@ -3967,20 +4168,330 @@
         </p:blipFill>
         <p:spPr>
           <a:xfrm>
-            <a:off x="4898789" y="1353363"/>
-            <a:ext cx="1806810" cy="4015134"/>
+            <a:off x="5043606" y="152399"/>
+            <a:ext cx="1661994" cy="830997"/>
           </a:xfrm>
           <a:prstGeom prst="rect">
             <a:avLst/>
           </a:prstGeom>
         </p:spPr>
       </p:pic>
+      <p:sp>
+        <p:nvSpPr>
+          <p:cNvPr id="15" name="Textfeld 14">
+            <a:extLst>
+              <a:ext uri="{FF2B5EF4-FFF2-40B4-BE49-F238E27FC236}">
+                <a16:creationId xmlns:a16="http://schemas.microsoft.com/office/drawing/2014/main" id="{26EA9E32-9108-CF90-E667-52FBE4E50A79}"/>
+              </a:ext>
+            </a:extLst>
+          </p:cNvPr>
+          <p:cNvSpPr txBox="1"/>
+          <p:nvPr/>
+        </p:nvSpPr>
+        <p:spPr>
+          <a:xfrm>
+            <a:off x="152400" y="1253698"/>
+            <a:ext cx="4549140" cy="1969770"/>
+          </a:xfrm>
+          <a:prstGeom prst="rect">
+            <a:avLst/>
+          </a:prstGeom>
+          <a:noFill/>
+        </p:spPr>
+        <p:txBody>
+          <a:bodyPr wrap="square" rtlCol="0">
+            <a:spAutoFit/>
+          </a:bodyPr>
+          <a:lstStyle/>
+          <a:p>
+            <a:r>
+              <a:rPr lang="en-US" sz="2400" b="1" noProof="0" dirty="0">
+                <a:solidFill>
+                  <a:srgbClr val="009682"/>
+                </a:solidFill>
+              </a:rPr>
+              <a:t>What is it?</a:t>
+            </a:r>
+          </a:p>
+          <a:p>
+            <a:pPr algn="just"/>
+            <a:r>
+              <a:rPr lang="en-US" sz="1400" noProof="0" dirty="0"/>
+              <a:t>Are you new to KIT or would you like to learn more about the campus? Then you're exactly right here! Our mobile web application </a:t>
+            </a:r>
+            <a:r>
+              <a:rPr lang="en-US" sz="1400" b="1" noProof="0" dirty="0"/>
+              <a:t>Explore KIT Campus</a:t>
+            </a:r>
+            <a:r>
+              <a:rPr lang="en-US" sz="1400" noProof="0" dirty="0"/>
+              <a:t> allows you to get an overview of the campus. Whether it's dining options, buildings, monuments, or parking, find out more about them in our app and use the routing function to get to your destination.</a:t>
+            </a:r>
+          </a:p>
+        </p:txBody>
+      </p:sp>
+      <p:sp>
+        <p:nvSpPr>
+          <p:cNvPr id="16" name="Textfeld 15">
+            <a:extLst>
+              <a:ext uri="{FF2B5EF4-FFF2-40B4-BE49-F238E27FC236}">
+                <a16:creationId xmlns:a16="http://schemas.microsoft.com/office/drawing/2014/main" id="{E6FD6E06-D069-4D14-DA3C-F254EB97FA28}"/>
+              </a:ext>
+            </a:extLst>
+          </p:cNvPr>
+          <p:cNvSpPr txBox="1"/>
+          <p:nvPr/>
+        </p:nvSpPr>
+        <p:spPr>
+          <a:xfrm>
+            <a:off x="2286522" y="3223468"/>
+            <a:ext cx="2506012" cy="4139595"/>
+          </a:xfrm>
+          <a:prstGeom prst="rect">
+            <a:avLst/>
+          </a:prstGeom>
+          <a:noFill/>
+        </p:spPr>
+        <p:txBody>
+          <a:bodyPr wrap="square" rtlCol="0">
+            <a:spAutoFit/>
+          </a:bodyPr>
+          <a:lstStyle/>
+          <a:p>
+            <a:r>
+              <a:rPr lang="en-US" sz="2400" b="1" noProof="0" dirty="0">
+                <a:solidFill>
+                  <a:srgbClr val="009682"/>
+                </a:solidFill>
+              </a:rPr>
+              <a:t>Features</a:t>
+            </a:r>
+          </a:p>
+          <a:p>
+            <a:r>
+              <a:rPr lang="en-US" sz="1400" b="1" noProof="0" dirty="0"/>
+              <a:t>Interactive Campus Map</a:t>
+            </a:r>
+          </a:p>
+          <a:p>
+            <a:pPr>
+              <a:spcAft>
+                <a:spcPts val="600"/>
+              </a:spcAft>
+            </a:pPr>
+            <a:r>
+              <a:rPr lang="en-US" sz="1400" noProof="0" dirty="0"/>
+              <a:t>Find all key places: buildings, parks, dining halls, and more.</a:t>
+            </a:r>
+            <a:endParaRPr lang="en-US" sz="1400" b="1" noProof="0" dirty="0"/>
+          </a:p>
+          <a:p>
+            <a:r>
+              <a:rPr lang="en-US" sz="1400" b="1" noProof="0" dirty="0"/>
+              <a:t>Detailed Information</a:t>
+            </a:r>
+          </a:p>
+          <a:p>
+            <a:pPr>
+              <a:spcAft>
+                <a:spcPts val="600"/>
+              </a:spcAft>
+            </a:pPr>
+            <a:r>
+              <a:rPr lang="en-US" sz="1400" noProof="0" dirty="0"/>
+              <a:t>Need specific information about a room, café, or building? Check the detailed information box.</a:t>
+            </a:r>
+          </a:p>
+          <a:p>
+            <a:r>
+              <a:rPr lang="en-US" sz="1400" b="1" noProof="0" dirty="0"/>
+              <a:t>Routing</a:t>
+            </a:r>
+          </a:p>
+          <a:p>
+            <a:pPr>
+              <a:spcAft>
+                <a:spcPts val="600"/>
+              </a:spcAft>
+            </a:pPr>
+            <a:r>
+              <a:rPr lang="en-US" sz="1400" noProof="0" dirty="0"/>
+              <a:t>Want to go somewhere? Plan your route across campus.</a:t>
+            </a:r>
+          </a:p>
+          <a:p>
+            <a:r>
+              <a:rPr lang="en-US" sz="1400" b="1" noProof="0" dirty="0"/>
+              <a:t>Weather</a:t>
+            </a:r>
+          </a:p>
+          <a:p>
+            <a:r>
+              <a:rPr lang="en-US" sz="1400" noProof="0" dirty="0"/>
+              <a:t>Planning an outdoor learning session? Check the current weather with the integrated weather panel.</a:t>
+            </a:r>
+          </a:p>
+        </p:txBody>
+      </p:sp>
+      <p:sp>
+        <p:nvSpPr>
+          <p:cNvPr id="17" name="Textfeld 16">
+            <a:extLst>
+              <a:ext uri="{FF2B5EF4-FFF2-40B4-BE49-F238E27FC236}">
+                <a16:creationId xmlns:a16="http://schemas.microsoft.com/office/drawing/2014/main" id="{B2A60626-FDE8-D21A-38FD-F60B0F852BBA}"/>
+              </a:ext>
+            </a:extLst>
+          </p:cNvPr>
+          <p:cNvSpPr txBox="1"/>
+          <p:nvPr/>
+        </p:nvSpPr>
+        <p:spPr>
+          <a:xfrm>
+            <a:off x="143510" y="7340410"/>
+            <a:ext cx="1706880" cy="1323439"/>
+          </a:xfrm>
+          <a:prstGeom prst="rect">
+            <a:avLst/>
+          </a:prstGeom>
+          <a:noFill/>
+        </p:spPr>
+        <p:txBody>
+          <a:bodyPr wrap="square" rtlCol="0">
+            <a:spAutoFit/>
+          </a:bodyPr>
+          <a:lstStyle/>
+          <a:p>
+            <a:r>
+              <a:rPr lang="en-US" sz="2400" b="1" noProof="0" dirty="0">
+                <a:solidFill>
+                  <a:srgbClr val="009682"/>
+                </a:solidFill>
+              </a:rPr>
+              <a:t>Try it now!</a:t>
+            </a:r>
+          </a:p>
+          <a:p>
+            <a:r>
+              <a:rPr lang="en-US" sz="1400" dirty="0"/>
+              <a:t>Available as browser preview. https://20korvin01.github.io/www/</a:t>
+            </a:r>
+            <a:endParaRPr lang="en-US" sz="1400" noProof="0" dirty="0"/>
+          </a:p>
+        </p:txBody>
+      </p:sp>
+      <p:sp>
+        <p:nvSpPr>
+          <p:cNvPr id="20" name="Textfeld 19">
+            <a:extLst>
+              <a:ext uri="{FF2B5EF4-FFF2-40B4-BE49-F238E27FC236}">
+                <a16:creationId xmlns:a16="http://schemas.microsoft.com/office/drawing/2014/main" id="{2803FF2B-0D0C-1406-A89B-0AEE7E77CBE0}"/>
+              </a:ext>
+            </a:extLst>
+          </p:cNvPr>
+          <p:cNvSpPr txBox="1"/>
+          <p:nvPr/>
+        </p:nvSpPr>
+        <p:spPr>
+          <a:xfrm>
+            <a:off x="1756700" y="7331342"/>
+            <a:ext cx="3035834" cy="1969770"/>
+          </a:xfrm>
+          <a:prstGeom prst="rect">
+            <a:avLst/>
+          </a:prstGeom>
+          <a:noFill/>
+        </p:spPr>
+        <p:txBody>
+          <a:bodyPr wrap="square" rtlCol="0">
+            <a:spAutoFit/>
+          </a:bodyPr>
+          <a:lstStyle/>
+          <a:p>
+            <a:r>
+              <a:rPr lang="en-US" sz="2400" noProof="0" dirty="0"/>
+              <a:t>  </a:t>
+            </a:r>
+            <a:r>
+              <a:rPr lang="en-US" sz="2400" b="1" noProof="0" dirty="0">
+                <a:solidFill>
+                  <a:srgbClr val="009682"/>
+                </a:solidFill>
+              </a:rPr>
+              <a:t>Why use the app?</a:t>
+            </a:r>
+          </a:p>
+          <a:p>
+            <a:pPr marL="285750" indent="-285750">
+              <a:buSzPct val="100000"/>
+              <a:buFont typeface="Wingdings" panose="05000000000000000000" pitchFamily="2" charset="2"/>
+              <a:buChar char="Ø"/>
+            </a:pPr>
+            <a:r>
+              <a:rPr lang="en-US" sz="1400" dirty="0"/>
+              <a:t>Orientation for </a:t>
+            </a:r>
+            <a:r>
+              <a:rPr lang="en-US" sz="1400" u="sng" dirty="0"/>
+              <a:t>first-year students</a:t>
+            </a:r>
+          </a:p>
+          <a:p>
+            <a:pPr marL="285750" indent="-285750">
+              <a:buSzPct val="100000"/>
+              <a:buFont typeface="Wingdings" panose="05000000000000000000" pitchFamily="2" charset="2"/>
+              <a:buChar char="Ø"/>
+            </a:pPr>
+            <a:r>
+              <a:rPr lang="en-US" sz="1400" noProof="0" dirty="0"/>
+              <a:t>Packed with information for </a:t>
+            </a:r>
+            <a:r>
+              <a:rPr lang="en-US" sz="1400" u="sng" noProof="0" dirty="0"/>
+              <a:t>visitors and guests</a:t>
+            </a:r>
+          </a:p>
+          <a:p>
+            <a:pPr marL="285750" indent="-285750">
+              <a:buSzPct val="100000"/>
+              <a:buFont typeface="Wingdings" panose="05000000000000000000" pitchFamily="2" charset="2"/>
+              <a:buChar char="Ø"/>
+            </a:pPr>
+            <a:r>
+              <a:rPr lang="en-US" sz="1400" dirty="0"/>
+              <a:t>Optimize routes on campus for </a:t>
+            </a:r>
+            <a:r>
+              <a:rPr lang="en-US" sz="1400" u="sng" dirty="0"/>
+              <a:t>students, staff and researchers</a:t>
+            </a:r>
+          </a:p>
+          <a:p>
+            <a:pPr marL="285750" indent="-285750">
+              <a:buSzPct val="100000"/>
+              <a:buFont typeface="Wingdings" panose="05000000000000000000" pitchFamily="2" charset="2"/>
+              <a:buChar char="Ø"/>
+            </a:pPr>
+            <a:r>
+              <a:rPr lang="en-US" sz="1400" noProof="0" dirty="0"/>
+              <a:t>For </a:t>
+            </a:r>
+            <a:r>
+              <a:rPr lang="en-US" sz="1400" u="sng" noProof="0" dirty="0"/>
+              <a:t>You</a:t>
+            </a:r>
+            <a:r>
+              <a:rPr lang="en-US" sz="1400" noProof="0" dirty="0"/>
+              <a:t> to explore KIT!</a:t>
+            </a:r>
+          </a:p>
+        </p:txBody>
+      </p:sp>
       <p:pic>
         <p:nvPicPr>
-          <p:cNvPr id="9" name="Grafik 8" descr="Ein Bild, das Text, Screenshot, Karte, Software enthält.&#10;&#10;KI-generierte Inhalte können fehlerhaft sein.">
+          <p:cNvPr id="26" name="Grafik 25">
             <a:extLst>
               <a:ext uri="{FF2B5EF4-FFF2-40B4-BE49-F238E27FC236}">
-                <a16:creationId xmlns:a16="http://schemas.microsoft.com/office/drawing/2014/main" id="{A77BA033-90EF-7787-1A8F-08DD1A245BB3}"/>
+                <a16:creationId xmlns:a16="http://schemas.microsoft.com/office/drawing/2014/main" id="{48CC6A89-BE8C-B08E-AB54-FF44B4FD71E0}"/>
               </a:ext>
             </a:extLst>
           </p:cNvPr>
@@ -3990,7 +4501,7 @@
           <p:nvPr/>
         </p:nvPicPr>
         <p:blipFill>
-          <a:blip r:embed="rId3" cstate="print">
+          <a:blip r:embed="rId3">
             <a:extLst>
               <a:ext uri="{28A0092B-C50C-407E-A947-70E740481C1C}">
                 <a14:useLocalDpi xmlns:a14="http://schemas.microsoft.com/office/drawing/2010/main" val="0"/>
@@ -4003,8 +4514,8 @@
         </p:blipFill>
         <p:spPr>
           <a:xfrm>
-            <a:off x="152399" y="3309103"/>
-            <a:ext cx="1806811" cy="4015135"/>
+            <a:off x="2149043" y="3348738"/>
+            <a:ext cx="228600" cy="228600"/>
           </a:xfrm>
           <a:prstGeom prst="rect">
             <a:avLst/>
@@ -4013,10 +4524,10 @@
       </p:pic>
       <p:pic>
         <p:nvPicPr>
-          <p:cNvPr id="11" name="Grafik 10" descr="Ein Bild, das Text, Software, Computersymbol, Betriebssystem enthält.&#10;&#10;KI-generierte Inhalte können fehlerhaft sein.">
+          <p:cNvPr id="28" name="Grafik 27">
             <a:extLst>
               <a:ext uri="{FF2B5EF4-FFF2-40B4-BE49-F238E27FC236}">
-                <a16:creationId xmlns:a16="http://schemas.microsoft.com/office/drawing/2014/main" id="{755F828F-68E5-96A7-697F-7F650B093185}"/>
+                <a16:creationId xmlns:a16="http://schemas.microsoft.com/office/drawing/2014/main" id="{34CB7D2C-403C-8F81-C7C4-4D5E77AB94E9}"/>
               </a:ext>
             </a:extLst>
           </p:cNvPr>
@@ -4026,7 +4537,7 @@
           <p:nvPr/>
         </p:nvPicPr>
         <p:blipFill>
-          <a:blip r:embed="rId4" cstate="print">
+          <a:blip r:embed="rId4">
             <a:extLst>
               <a:ext uri="{28A0092B-C50C-407E-A947-70E740481C1C}">
                 <a14:useLocalDpi xmlns:a14="http://schemas.microsoft.com/office/drawing/2010/main" val="0"/>
@@ -4039,69 +4550,20 @@
         </p:blipFill>
         <p:spPr>
           <a:xfrm>
-            <a:off x="4898788" y="5738464"/>
-            <a:ext cx="1806811" cy="4015135"/>
+            <a:off x="2149043" y="3607482"/>
+            <a:ext cx="228600" cy="228600"/>
           </a:xfrm>
           <a:prstGeom prst="rect">
             <a:avLst/>
           </a:prstGeom>
         </p:spPr>
       </p:pic>
-      <p:sp>
-        <p:nvSpPr>
-          <p:cNvPr id="12" name="Textfeld 11">
-            <a:extLst>
-              <a:ext uri="{FF2B5EF4-FFF2-40B4-BE49-F238E27FC236}">
-                <a16:creationId xmlns:a16="http://schemas.microsoft.com/office/drawing/2014/main" id="{27BD1FBA-FEA5-86C7-A7D4-727019A5298C}"/>
-              </a:ext>
-            </a:extLst>
-          </p:cNvPr>
-          <p:cNvSpPr txBox="1"/>
-          <p:nvPr/>
-        </p:nvSpPr>
-        <p:spPr>
-          <a:xfrm>
-            <a:off x="152400" y="9379010"/>
-            <a:ext cx="4434227" cy="430887"/>
-          </a:xfrm>
-          <a:prstGeom prst="rect">
-            <a:avLst/>
-          </a:prstGeom>
-          <a:noFill/>
-        </p:spPr>
-        <p:txBody>
-          <a:bodyPr wrap="none" rtlCol="0">
-            <a:spAutoFit/>
-          </a:bodyPr>
-          <a:lstStyle/>
-          <a:p>
-            <a:r>
-              <a:rPr lang="en-US" sz="1100" noProof="0" dirty="0"/>
-              <a:t>Korvin Brecht – Jasmin </a:t>
-            </a:r>
-            <a:r>
-              <a:rPr lang="en-US" sz="1100" noProof="0" dirty="0" err="1"/>
-              <a:t>Jährling</a:t>
-            </a:r>
-            <a:r>
-              <a:rPr lang="en-US" sz="1100" noProof="0" dirty="0"/>
-              <a:t> – Elisabeth Kral – Merlin Pillich</a:t>
-            </a:r>
-          </a:p>
-          <a:p>
-            <a:r>
-              <a:rPr lang="en-US" sz="1100" noProof="0" dirty="0"/>
-              <a:t>Mobile GIS – Summer Semester 2025 – Dr.-Ing. Paul Vincent Kuper</a:t>
-            </a:r>
-          </a:p>
-        </p:txBody>
-      </p:sp>
       <p:pic>
         <p:nvPicPr>
-          <p:cNvPr id="14" name="Grafik 13" descr="Ein Bild, das Grafiken, Screenshot, Grafikdesign, Farbigkeit enthält.&#10;&#10;KI-generierte Inhalte können fehlerhaft sein.">
+          <p:cNvPr id="30" name="Grafik 29">
             <a:extLst>
               <a:ext uri="{FF2B5EF4-FFF2-40B4-BE49-F238E27FC236}">
-                <a16:creationId xmlns:a16="http://schemas.microsoft.com/office/drawing/2014/main" id="{3BDF71EC-75B6-67C1-DC68-CC92E36163FD}"/>
+                <a16:creationId xmlns:a16="http://schemas.microsoft.com/office/drawing/2014/main" id="{BA78BE99-E576-2D24-BCBA-63DB6E008F66}"/>
               </a:ext>
             </a:extLst>
           </p:cNvPr>
@@ -4111,7 +4573,7 @@
           <p:nvPr/>
         </p:nvPicPr>
         <p:blipFill>
-          <a:blip r:embed="rId5" cstate="print">
+          <a:blip r:embed="rId5">
             <a:extLst>
               <a:ext uri="{28A0092B-C50C-407E-A947-70E740481C1C}">
                 <a14:useLocalDpi xmlns:a14="http://schemas.microsoft.com/office/drawing/2010/main" val="0"/>
@@ -4124,325 +4586,20 @@
         </p:blipFill>
         <p:spPr>
           <a:xfrm>
-            <a:off x="5043606" y="152399"/>
-            <a:ext cx="1661994" cy="830997"/>
+            <a:off x="2149043" y="6186233"/>
+            <a:ext cx="228600" cy="228600"/>
           </a:xfrm>
           <a:prstGeom prst="rect">
             <a:avLst/>
           </a:prstGeom>
         </p:spPr>
       </p:pic>
-      <p:sp>
-        <p:nvSpPr>
-          <p:cNvPr id="15" name="Textfeld 14">
-            <a:extLst>
-              <a:ext uri="{FF2B5EF4-FFF2-40B4-BE49-F238E27FC236}">
-                <a16:creationId xmlns:a16="http://schemas.microsoft.com/office/drawing/2014/main" id="{26EA9E32-9108-CF90-E667-52FBE4E50A79}"/>
-              </a:ext>
-            </a:extLst>
-          </p:cNvPr>
-          <p:cNvSpPr txBox="1"/>
-          <p:nvPr/>
-        </p:nvSpPr>
-        <p:spPr>
-          <a:xfrm>
-            <a:off x="152400" y="1253698"/>
-            <a:ext cx="4549140" cy="1969770"/>
-          </a:xfrm>
-          <a:prstGeom prst="rect">
-            <a:avLst/>
-          </a:prstGeom>
-          <a:noFill/>
-        </p:spPr>
-        <p:txBody>
-          <a:bodyPr wrap="square" rtlCol="0">
-            <a:spAutoFit/>
-          </a:bodyPr>
-          <a:lstStyle/>
-          <a:p>
-            <a:r>
-              <a:rPr lang="en-US" sz="2400" b="1" noProof="0" dirty="0">
-                <a:solidFill>
-                  <a:srgbClr val="009682"/>
-                </a:solidFill>
-              </a:rPr>
-              <a:t>What is it?</a:t>
-            </a:r>
-          </a:p>
-          <a:p>
-            <a:pPr algn="just"/>
-            <a:r>
-              <a:rPr lang="en-US" sz="1400" noProof="0" dirty="0"/>
-              <a:t>Are you new to KIT or would you like to learn more about the campus? Then you're exactly right here! Our mobile web application </a:t>
-            </a:r>
-            <a:r>
-              <a:rPr lang="en-US" sz="1400" b="1" noProof="0" dirty="0"/>
-              <a:t>Explore KIT Campus</a:t>
-            </a:r>
-            <a:r>
-              <a:rPr lang="en-US" sz="1400" noProof="0" dirty="0"/>
-              <a:t> allows you to get an overview of the campus. Whether it's dining options, buildings, monuments, or parking, find out more about them in our app and use the routing function to get to your destination.</a:t>
-            </a:r>
-          </a:p>
-        </p:txBody>
-      </p:sp>
-      <p:sp>
-        <p:nvSpPr>
-          <p:cNvPr id="16" name="Textfeld 15">
-            <a:extLst>
-              <a:ext uri="{FF2B5EF4-FFF2-40B4-BE49-F238E27FC236}">
-                <a16:creationId xmlns:a16="http://schemas.microsoft.com/office/drawing/2014/main" id="{E6FD6E06-D069-4D14-DA3C-F254EB97FA28}"/>
-              </a:ext>
-            </a:extLst>
-          </p:cNvPr>
-          <p:cNvSpPr txBox="1"/>
-          <p:nvPr/>
-        </p:nvSpPr>
-        <p:spPr>
-          <a:xfrm>
-            <a:off x="2262677" y="3223468"/>
-            <a:ext cx="2629953" cy="4139595"/>
-          </a:xfrm>
-          <a:prstGeom prst="rect">
-            <a:avLst/>
-          </a:prstGeom>
-          <a:noFill/>
-        </p:spPr>
-        <p:txBody>
-          <a:bodyPr wrap="square" rtlCol="0">
-            <a:spAutoFit/>
-          </a:bodyPr>
-          <a:lstStyle/>
-          <a:p>
-            <a:r>
-              <a:rPr lang="en-US" sz="2400" b="1" noProof="0" dirty="0">
-                <a:solidFill>
-                  <a:srgbClr val="009682"/>
-                </a:solidFill>
-              </a:rPr>
-              <a:t>Features</a:t>
-            </a:r>
-          </a:p>
-          <a:p>
-            <a:r>
-              <a:rPr lang="en-US" sz="1400" b="1" noProof="0" dirty="0"/>
-              <a:t>Interactive Campus Map</a:t>
-            </a:r>
-          </a:p>
-          <a:p>
-            <a:pPr>
-              <a:spcAft>
-                <a:spcPts val="600"/>
-              </a:spcAft>
-            </a:pPr>
-            <a:r>
-              <a:rPr lang="en-US" sz="1400" noProof="0" dirty="0"/>
-              <a:t>Find all key places – buildings, parks, dining halls, and more.</a:t>
-            </a:r>
-            <a:endParaRPr lang="en-US" sz="1400" b="1" noProof="0" dirty="0"/>
-          </a:p>
-          <a:p>
-            <a:r>
-              <a:rPr lang="en-US" sz="1400" b="1" noProof="0" dirty="0"/>
-              <a:t>Detailed Information</a:t>
-            </a:r>
-          </a:p>
-          <a:p>
-            <a:pPr>
-              <a:spcAft>
-                <a:spcPts val="600"/>
-              </a:spcAft>
-            </a:pPr>
-            <a:r>
-              <a:rPr lang="en-US" sz="1400" noProof="0" dirty="0"/>
-              <a:t>Need specific information about a room, café, or building? Check the detailed information box.</a:t>
-            </a:r>
-          </a:p>
-          <a:p>
-            <a:r>
-              <a:rPr lang="en-US" sz="1400" b="1" noProof="0" dirty="0"/>
-              <a:t>Routing</a:t>
-            </a:r>
-          </a:p>
-          <a:p>
-            <a:pPr>
-              <a:spcAft>
-                <a:spcPts val="600"/>
-              </a:spcAft>
-            </a:pPr>
-            <a:r>
-              <a:rPr lang="en-US" sz="1400" noProof="0" dirty="0"/>
-              <a:t>Want to go somewhere? Plan your route across campus.</a:t>
-            </a:r>
-          </a:p>
-          <a:p>
-            <a:r>
-              <a:rPr lang="en-US" sz="1400" b="1" noProof="0" dirty="0"/>
-              <a:t>Weather</a:t>
-            </a:r>
-          </a:p>
-          <a:p>
-            <a:r>
-              <a:rPr lang="en-US" sz="1400" noProof="0" dirty="0"/>
-              <a:t>Planning an outdoor learning session? Check the current weather with the integrated weather panel.</a:t>
-            </a:r>
-          </a:p>
-        </p:txBody>
-      </p:sp>
-      <p:sp>
-        <p:nvSpPr>
-          <p:cNvPr id="17" name="Textfeld 16">
-            <a:extLst>
-              <a:ext uri="{FF2B5EF4-FFF2-40B4-BE49-F238E27FC236}">
-                <a16:creationId xmlns:a16="http://schemas.microsoft.com/office/drawing/2014/main" id="{B2A60626-FDE8-D21A-38FD-F60B0F852BBA}"/>
-              </a:ext>
-            </a:extLst>
-          </p:cNvPr>
-          <p:cNvSpPr txBox="1"/>
-          <p:nvPr/>
-        </p:nvSpPr>
-        <p:spPr>
-          <a:xfrm>
-            <a:off x="152400" y="7409873"/>
-            <a:ext cx="1706880" cy="892552"/>
-          </a:xfrm>
-          <a:prstGeom prst="rect">
-            <a:avLst/>
-          </a:prstGeom>
-          <a:noFill/>
-        </p:spPr>
-        <p:txBody>
-          <a:bodyPr wrap="square" rtlCol="0">
-            <a:spAutoFit/>
-          </a:bodyPr>
-          <a:lstStyle/>
-          <a:p>
-            <a:r>
-              <a:rPr lang="en-US" sz="2400" b="1" noProof="0" dirty="0">
-                <a:solidFill>
-                  <a:srgbClr val="009682"/>
-                </a:solidFill>
-              </a:rPr>
-              <a:t>Try it now!</a:t>
-            </a:r>
-          </a:p>
-          <a:p>
-            <a:r>
-              <a:rPr lang="en-US" sz="1400" noProof="0" dirty="0"/>
-              <a:t>https://github.com/20korvin01/www/</a:t>
-            </a:r>
-          </a:p>
-        </p:txBody>
-      </p:sp>
-      <p:sp>
-        <p:nvSpPr>
-          <p:cNvPr id="20" name="Textfeld 19">
-            <a:extLst>
-              <a:ext uri="{FF2B5EF4-FFF2-40B4-BE49-F238E27FC236}">
-                <a16:creationId xmlns:a16="http://schemas.microsoft.com/office/drawing/2014/main" id="{2803FF2B-0D0C-1406-A89B-0AEE7E77CBE0}"/>
-              </a:ext>
-            </a:extLst>
-          </p:cNvPr>
-          <p:cNvSpPr txBox="1"/>
-          <p:nvPr/>
-        </p:nvSpPr>
-        <p:spPr>
-          <a:xfrm>
-            <a:off x="1859280" y="7409873"/>
-            <a:ext cx="3033350" cy="1969770"/>
-          </a:xfrm>
-          <a:prstGeom prst="rect">
-            <a:avLst/>
-          </a:prstGeom>
-          <a:noFill/>
-        </p:spPr>
-        <p:txBody>
-          <a:bodyPr wrap="square" rtlCol="0">
-            <a:spAutoFit/>
-          </a:bodyPr>
-          <a:lstStyle/>
-          <a:p>
-            <a:r>
-              <a:rPr lang="en-US" sz="2400" noProof="0" dirty="0"/>
-              <a:t>  </a:t>
-            </a:r>
-            <a:r>
-              <a:rPr lang="en-US" sz="2400" b="1" noProof="0" dirty="0">
-                <a:solidFill>
-                  <a:srgbClr val="009682"/>
-                </a:solidFill>
-              </a:rPr>
-              <a:t>Why use the app?</a:t>
-            </a:r>
-          </a:p>
-          <a:p>
-            <a:pPr marL="285750" indent="-285750">
-              <a:buSzPct val="100000"/>
-              <a:buFont typeface="Wingdings" panose="05000000000000000000" pitchFamily="2" charset="2"/>
-              <a:buChar char="Ø"/>
-            </a:pPr>
-            <a:r>
-              <a:rPr lang="en-US" sz="1400" dirty="0"/>
-              <a:t>Orientation for </a:t>
-            </a:r>
-            <a:r>
-              <a:rPr lang="en-US" sz="1400" u="sng" dirty="0"/>
-              <a:t>first-year students</a:t>
-            </a:r>
-          </a:p>
-          <a:p>
-            <a:pPr marL="285750" indent="-285750">
-              <a:buSzPct val="100000"/>
-              <a:buFont typeface="Wingdings" panose="05000000000000000000" pitchFamily="2" charset="2"/>
-              <a:buChar char="Ø"/>
-            </a:pPr>
-            <a:r>
-              <a:rPr lang="en-US" sz="1400" noProof="0" dirty="0"/>
-              <a:t>Packed with information for </a:t>
-            </a:r>
-            <a:r>
-              <a:rPr lang="en-US" sz="1400" u="sng" noProof="0" dirty="0"/>
-              <a:t>visitors and guests</a:t>
-            </a:r>
-          </a:p>
-          <a:p>
-            <a:pPr marL="285750" indent="-285750">
-              <a:buSzPct val="100000"/>
-              <a:buFont typeface="Wingdings" panose="05000000000000000000" pitchFamily="2" charset="2"/>
-              <a:buChar char="Ø"/>
-            </a:pPr>
-            <a:r>
-              <a:rPr lang="en-US" sz="1400" dirty="0"/>
-              <a:t>Optimize routes on campus for </a:t>
-            </a:r>
-            <a:r>
-              <a:rPr lang="en-US" sz="1400" u="sng" dirty="0"/>
-              <a:t>students, staff and researchers</a:t>
-            </a:r>
-          </a:p>
-          <a:p>
-            <a:pPr marL="285750" indent="-285750">
-              <a:buSzPct val="100000"/>
-              <a:buFont typeface="Wingdings" panose="05000000000000000000" pitchFamily="2" charset="2"/>
-              <a:buChar char="Ø"/>
-            </a:pPr>
-            <a:r>
-              <a:rPr lang="en-US" sz="1400" u="sng" noProof="0" dirty="0"/>
-              <a:t>Anyone</a:t>
-            </a:r>
-            <a:r>
-              <a:rPr lang="en-US" sz="1400" noProof="0" dirty="0"/>
-              <a:t> curious about KIT!</a:t>
-            </a:r>
-          </a:p>
-        </p:txBody>
-      </p:sp>
       <p:pic>
         <p:nvPicPr>
-          <p:cNvPr id="22" name="Grafik 21" descr="Ein Bild, das Muster, Design, Quadrat, Pixel enthält.&#10;&#10;KI-generierte Inhalte können fehlerhaft sein.">
+          <p:cNvPr id="32" name="Grafik 31">
             <a:extLst>
               <a:ext uri="{FF2B5EF4-FFF2-40B4-BE49-F238E27FC236}">
-                <a16:creationId xmlns:a16="http://schemas.microsoft.com/office/drawing/2014/main" id="{A9B24C8F-EA5B-D632-25C7-653AD551E78C}"/>
+                <a16:creationId xmlns:a16="http://schemas.microsoft.com/office/drawing/2014/main" id="{30B219D2-7940-6049-944F-2CE23EBE5F62}"/>
               </a:ext>
             </a:extLst>
           </p:cNvPr>
@@ -4452,7 +4609,7 @@
           <p:nvPr/>
         </p:nvPicPr>
         <p:blipFill>
-          <a:blip r:embed="rId6" cstate="print">
+          <a:blip r:embed="rId6">
             <a:extLst>
               <a:ext uri="{28A0092B-C50C-407E-A947-70E740481C1C}">
                 <a14:useLocalDpi xmlns:a14="http://schemas.microsoft.com/office/drawing/2010/main" val="0"/>
@@ -4465,8 +4622,8 @@
         </p:blipFill>
         <p:spPr>
           <a:xfrm>
-            <a:off x="425834" y="8296815"/>
-            <a:ext cx="1088892" cy="1088892"/>
+            <a:off x="2149043" y="5501052"/>
+            <a:ext cx="228600" cy="228600"/>
           </a:xfrm>
           <a:prstGeom prst="rect">
             <a:avLst/>
@@ -4475,10 +4632,10 @@
       </p:pic>
       <p:pic>
         <p:nvPicPr>
-          <p:cNvPr id="26" name="Grafik 25">
+          <p:cNvPr id="34" name="Grafik 33">
             <a:extLst>
               <a:ext uri="{FF2B5EF4-FFF2-40B4-BE49-F238E27FC236}">
-                <a16:creationId xmlns:a16="http://schemas.microsoft.com/office/drawing/2014/main" id="{48CC6A89-BE8C-B08E-AB54-FF44B4FD71E0}"/>
+                <a16:creationId xmlns:a16="http://schemas.microsoft.com/office/drawing/2014/main" id="{6ACE7832-AC9A-1B13-9C81-F53A25F9A505}"/>
               </a:ext>
             </a:extLst>
           </p:cNvPr>
@@ -4501,7 +4658,7 @@
         </p:blipFill>
         <p:spPr>
           <a:xfrm>
-            <a:off x="2110943" y="3348738"/>
+            <a:off x="2149043" y="4343463"/>
             <a:ext cx="228600" cy="228600"/>
           </a:xfrm>
           <a:prstGeom prst="rect">
@@ -4511,10 +4668,10 @@
       </p:pic>
       <p:pic>
         <p:nvPicPr>
-          <p:cNvPr id="28" name="Grafik 27">
+          <p:cNvPr id="3" name="Grafik 2" descr="Ein Bild, das Text, Karte, Handy, Screenshot enthält.&#10;&#10;KI-generierte Inhalte können fehlerhaft sein.">
             <a:extLst>
               <a:ext uri="{FF2B5EF4-FFF2-40B4-BE49-F238E27FC236}">
-                <a16:creationId xmlns:a16="http://schemas.microsoft.com/office/drawing/2014/main" id="{34CB7D2C-403C-8F81-C7C4-4D5E77AB94E9}"/>
+                <a16:creationId xmlns:a16="http://schemas.microsoft.com/office/drawing/2014/main" id="{A333A9D2-1B2E-F964-5CB0-F1BD8031522D}"/>
               </a:ext>
             </a:extLst>
           </p:cNvPr>
@@ -4524,7 +4681,7 @@
           <p:nvPr/>
         </p:nvPicPr>
         <p:blipFill>
-          <a:blip r:embed="rId8">
+          <a:blip r:embed="rId8" cstate="print">
             <a:extLst>
               <a:ext uri="{28A0092B-C50C-407E-A947-70E740481C1C}">
                 <a14:useLocalDpi xmlns:a14="http://schemas.microsoft.com/office/drawing/2010/main" val="0"/>
@@ -4537,20 +4694,20 @@
         </p:blipFill>
         <p:spPr>
           <a:xfrm>
-            <a:off x="2110943" y="3607482"/>
-            <a:ext cx="228600" cy="228600"/>
-          </a:xfrm>
-          <a:prstGeom prst="rect">
+            <a:off x="4792534" y="1253454"/>
+            <a:ext cx="1958340" cy="3916679"/>
+          </a:xfrm>
+          <a:prstGeom prst="roundRect">
             <a:avLst/>
           </a:prstGeom>
         </p:spPr>
       </p:pic>
       <p:pic>
         <p:nvPicPr>
-          <p:cNvPr id="30" name="Grafik 29">
+          <p:cNvPr id="10" name="Grafik 9" descr="Ein Bild, das Text, Handy, Screenshot, Kommunikationsgerät enthält.&#10;&#10;KI-generierte Inhalte können fehlerhaft sein.">
             <a:extLst>
               <a:ext uri="{FF2B5EF4-FFF2-40B4-BE49-F238E27FC236}">
-                <a16:creationId xmlns:a16="http://schemas.microsoft.com/office/drawing/2014/main" id="{BA78BE99-E576-2D24-BCBA-63DB6E008F66}"/>
+                <a16:creationId xmlns:a16="http://schemas.microsoft.com/office/drawing/2014/main" id="{CCD4F9DC-A8CB-FE43-1264-503A9D68679E}"/>
               </a:ext>
             </a:extLst>
           </p:cNvPr>
@@ -4560,7 +4717,7 @@
           <p:nvPr/>
         </p:nvPicPr>
         <p:blipFill>
-          <a:blip r:embed="rId9">
+          <a:blip r:embed="rId9" cstate="print">
             <a:extLst>
               <a:ext uri="{28A0092B-C50C-407E-A947-70E740481C1C}">
                 <a14:useLocalDpi xmlns:a14="http://schemas.microsoft.com/office/drawing/2010/main" val="0"/>
@@ -4573,20 +4730,20 @@
         </p:blipFill>
         <p:spPr>
           <a:xfrm>
-            <a:off x="2110943" y="6656133"/>
-            <a:ext cx="228600" cy="228600"/>
-          </a:xfrm>
-          <a:prstGeom prst="rect">
+            <a:off x="121964" y="3336299"/>
+            <a:ext cx="1958340" cy="3916679"/>
+          </a:xfrm>
+          <a:prstGeom prst="roundRect">
             <a:avLst/>
           </a:prstGeom>
         </p:spPr>
       </p:pic>
       <p:pic>
         <p:nvPicPr>
-          <p:cNvPr id="32" name="Grafik 31">
+          <p:cNvPr id="18" name="Grafik 17" descr="Ein Bild, das Text, Handy, Screenshot, Kommunikationsgerät enthält.&#10;&#10;KI-generierte Inhalte können fehlerhaft sein.">
             <a:extLst>
               <a:ext uri="{FF2B5EF4-FFF2-40B4-BE49-F238E27FC236}">
-                <a16:creationId xmlns:a16="http://schemas.microsoft.com/office/drawing/2014/main" id="{30B219D2-7940-6049-944F-2CE23EBE5F62}"/>
+                <a16:creationId xmlns:a16="http://schemas.microsoft.com/office/drawing/2014/main" id="{E7FCBC85-3E96-0295-FF4E-292E4B59720F}"/>
               </a:ext>
             </a:extLst>
           </p:cNvPr>
@@ -4596,7 +4753,7 @@
           <p:nvPr/>
         </p:nvPicPr>
         <p:blipFill>
-          <a:blip r:embed="rId10">
+          <a:blip r:embed="rId10" cstate="print">
             <a:extLst>
               <a:ext uri="{28A0092B-C50C-407E-A947-70E740481C1C}">
                 <a14:useLocalDpi xmlns:a14="http://schemas.microsoft.com/office/drawing/2010/main" val="0"/>
@@ -4609,20 +4766,20 @@
         </p:blipFill>
         <p:spPr>
           <a:xfrm>
-            <a:off x="2110943" y="5691552"/>
-            <a:ext cx="228600" cy="228600"/>
-          </a:xfrm>
-          <a:prstGeom prst="rect">
+            <a:off x="4777696" y="5305825"/>
+            <a:ext cx="1958340" cy="3916679"/>
+          </a:xfrm>
+          <a:prstGeom prst="roundRect">
             <a:avLst/>
           </a:prstGeom>
         </p:spPr>
       </p:pic>
       <p:pic>
         <p:nvPicPr>
-          <p:cNvPr id="34" name="Grafik 33">
+          <p:cNvPr id="21" name="Grafik 20" descr="Ein Bild, das Muster, Design, Grafiken, Quadrat enthält.&#10;&#10;KI-generierte Inhalte können fehlerhaft sein.">
             <a:extLst>
               <a:ext uri="{FF2B5EF4-FFF2-40B4-BE49-F238E27FC236}">
-                <a16:creationId xmlns:a16="http://schemas.microsoft.com/office/drawing/2014/main" id="{6ACE7832-AC9A-1B13-9C81-F53A25F9A505}"/>
+                <a16:creationId xmlns:a16="http://schemas.microsoft.com/office/drawing/2014/main" id="{B5E4DB5B-F534-C448-013D-D4B2A48A0EF5}"/>
               </a:ext>
             </a:extLst>
           </p:cNvPr>
@@ -4632,7 +4789,7 @@
           <p:nvPr/>
         </p:nvPicPr>
         <p:blipFill>
-          <a:blip r:embed="rId11">
+          <a:blip r:embed="rId11" cstate="print">
             <a:extLst>
               <a:ext uri="{28A0092B-C50C-407E-A947-70E740481C1C}">
                 <a14:useLocalDpi xmlns:a14="http://schemas.microsoft.com/office/drawing/2010/main" val="0"/>
@@ -4645,8 +4802,8 @@
         </p:blipFill>
         <p:spPr>
           <a:xfrm>
-            <a:off x="2110943" y="4572063"/>
-            <a:ext cx="228600" cy="228600"/>
+            <a:off x="444500" y="8666788"/>
+            <a:ext cx="1096896" cy="1096896"/>
           </a:xfrm>
           <a:prstGeom prst="rect">
             <a:avLst/>
@@ -4667,6 +4824,1600 @@
 </file>
 
 <file path=ppt/slides/slide2.xml><?xml version="1.0" encoding="utf-8"?>
+<p:sld xmlns:a="http://schemas.openxmlformats.org/drawingml/2006/main" xmlns:r="http://schemas.openxmlformats.org/officeDocument/2006/relationships" xmlns:p="http://schemas.openxmlformats.org/presentationml/2006/main">
+  <p:cSld>
+    <p:spTree>
+      <p:nvGrpSpPr>
+        <p:cNvPr id="1" name="">
+          <a:extLst>
+            <a:ext uri="{FF2B5EF4-FFF2-40B4-BE49-F238E27FC236}">
+              <a16:creationId xmlns:a16="http://schemas.microsoft.com/office/drawing/2014/main" id="{0540241E-D145-B7DE-CAF2-52095F0C16FF}"/>
+            </a:ext>
+          </a:extLst>
+        </p:cNvPr>
+        <p:cNvGrpSpPr/>
+        <p:nvPr/>
+      </p:nvGrpSpPr>
+      <p:grpSpPr>
+        <a:xfrm>
+          <a:off x="0" y="0"/>
+          <a:ext cx="0" cy="0"/>
+          <a:chOff x="0" y="0"/>
+          <a:chExt cx="0" cy="0"/>
+        </a:xfrm>
+      </p:grpSpPr>
+      <p:sp>
+        <p:nvSpPr>
+          <p:cNvPr id="4" name="Textfeld 3">
+            <a:extLst>
+              <a:ext uri="{FF2B5EF4-FFF2-40B4-BE49-F238E27FC236}">
+                <a16:creationId xmlns:a16="http://schemas.microsoft.com/office/drawing/2014/main" id="{C1F04D13-8D16-4EB6-B391-75AFBCB758B1}"/>
+              </a:ext>
+            </a:extLst>
+          </p:cNvPr>
+          <p:cNvSpPr txBox="1"/>
+          <p:nvPr/>
+        </p:nvSpPr>
+        <p:spPr>
+          <a:xfrm>
+            <a:off x="154934" y="152400"/>
+            <a:ext cx="4433906" cy="1015663"/>
+          </a:xfrm>
+          <a:prstGeom prst="rect">
+            <a:avLst/>
+          </a:prstGeom>
+          <a:noFill/>
+        </p:spPr>
+        <p:txBody>
+          <a:bodyPr wrap="none" rtlCol="0">
+            <a:spAutoFit/>
+          </a:bodyPr>
+          <a:lstStyle/>
+          <a:p>
+            <a:r>
+              <a:rPr lang="en-US" sz="3600" noProof="0" dirty="0"/>
+              <a:t>Explore KIT Campus</a:t>
+            </a:r>
+          </a:p>
+          <a:p>
+            <a:r>
+              <a:rPr lang="en-US" sz="2400" noProof="0" dirty="0"/>
+              <a:t>Discover, Navigate, Enjoy.</a:t>
+            </a:r>
+          </a:p>
+        </p:txBody>
+      </p:sp>
+      <p:sp>
+        <p:nvSpPr>
+          <p:cNvPr id="12" name="Textfeld 11">
+            <a:extLst>
+              <a:ext uri="{FF2B5EF4-FFF2-40B4-BE49-F238E27FC236}">
+                <a16:creationId xmlns:a16="http://schemas.microsoft.com/office/drawing/2014/main" id="{8C22228D-2708-CA64-5C32-10FBCF17F033}"/>
+              </a:ext>
+            </a:extLst>
+          </p:cNvPr>
+          <p:cNvSpPr txBox="1"/>
+          <p:nvPr/>
+        </p:nvSpPr>
+        <p:spPr>
+          <a:xfrm>
+            <a:off x="1850389" y="9358197"/>
+            <a:ext cx="4900485" cy="461665"/>
+          </a:xfrm>
+          <a:prstGeom prst="rect">
+            <a:avLst/>
+          </a:prstGeom>
+          <a:noFill/>
+        </p:spPr>
+        <p:txBody>
+          <a:bodyPr wrap="square" rtlCol="0">
+            <a:spAutoFit/>
+          </a:bodyPr>
+          <a:lstStyle/>
+          <a:p>
+            <a:pPr algn="r"/>
+            <a:r>
+              <a:rPr lang="en-US" sz="1200" noProof="0" dirty="0"/>
+              <a:t>Korvin Brecht – Jasmin </a:t>
+            </a:r>
+            <a:r>
+              <a:rPr lang="en-US" sz="1200" noProof="0" dirty="0" err="1"/>
+              <a:t>Jährling</a:t>
+            </a:r>
+            <a:r>
+              <a:rPr lang="en-US" sz="1200" noProof="0" dirty="0"/>
+              <a:t> – Elisabeth Kral – Merlin Pillich</a:t>
+            </a:r>
+          </a:p>
+          <a:p>
+            <a:pPr algn="r"/>
+            <a:r>
+              <a:rPr lang="en-US" sz="1200" noProof="0" dirty="0"/>
+              <a:t>Mobile GIS – Summer Semester 2025 </a:t>
+            </a:r>
+            <a:r>
+              <a:rPr lang="en-US" sz="1200" dirty="0"/>
+              <a:t>– Dr.-Ing. Paul Vincent Kuper</a:t>
+            </a:r>
+            <a:endParaRPr lang="en-US" sz="1200" noProof="0" dirty="0"/>
+          </a:p>
+        </p:txBody>
+      </p:sp>
+      <p:pic>
+        <p:nvPicPr>
+          <p:cNvPr id="14" name="Grafik 13" descr="Ein Bild, das Grafiken, Screenshot, Grafikdesign, Farbigkeit enthält.&#10;&#10;KI-generierte Inhalte können fehlerhaft sein.">
+            <a:extLst>
+              <a:ext uri="{FF2B5EF4-FFF2-40B4-BE49-F238E27FC236}">
+                <a16:creationId xmlns:a16="http://schemas.microsoft.com/office/drawing/2014/main" id="{73DA48C8-E9AA-AE55-95AB-FBA692ACF3E4}"/>
+              </a:ext>
+            </a:extLst>
+          </p:cNvPr>
+          <p:cNvPicPr>
+            <a:picLocks noChangeAspect="1"/>
+          </p:cNvPicPr>
+          <p:nvPr/>
+        </p:nvPicPr>
+        <p:blipFill>
+          <a:blip r:embed="rId2" cstate="print">
+            <a:extLst>
+              <a:ext uri="{28A0092B-C50C-407E-A947-70E740481C1C}">
+                <a14:useLocalDpi xmlns:a14="http://schemas.microsoft.com/office/drawing/2010/main" val="0"/>
+              </a:ext>
+            </a:extLst>
+          </a:blip>
+          <a:stretch>
+            <a:fillRect/>
+          </a:stretch>
+        </p:blipFill>
+        <p:spPr>
+          <a:xfrm>
+            <a:off x="5043606" y="152399"/>
+            <a:ext cx="1661994" cy="830997"/>
+          </a:xfrm>
+          <a:prstGeom prst="rect">
+            <a:avLst/>
+          </a:prstGeom>
+        </p:spPr>
+      </p:pic>
+      <p:sp>
+        <p:nvSpPr>
+          <p:cNvPr id="15" name="Textfeld 14">
+            <a:extLst>
+              <a:ext uri="{FF2B5EF4-FFF2-40B4-BE49-F238E27FC236}">
+                <a16:creationId xmlns:a16="http://schemas.microsoft.com/office/drawing/2014/main" id="{E1F581F7-A936-C20B-A5A2-BECEACA6D8CF}"/>
+              </a:ext>
+            </a:extLst>
+          </p:cNvPr>
+          <p:cNvSpPr txBox="1"/>
+          <p:nvPr/>
+        </p:nvSpPr>
+        <p:spPr>
+          <a:xfrm>
+            <a:off x="152400" y="1253698"/>
+            <a:ext cx="4549140" cy="1969770"/>
+          </a:xfrm>
+          <a:prstGeom prst="rect">
+            <a:avLst/>
+          </a:prstGeom>
+          <a:noFill/>
+        </p:spPr>
+        <p:txBody>
+          <a:bodyPr wrap="square" rtlCol="0">
+            <a:spAutoFit/>
+          </a:bodyPr>
+          <a:lstStyle/>
+          <a:p>
+            <a:r>
+              <a:rPr lang="en-US" sz="2400" b="1" noProof="0" dirty="0">
+                <a:solidFill>
+                  <a:srgbClr val="009682"/>
+                </a:solidFill>
+              </a:rPr>
+              <a:t>What is it?</a:t>
+            </a:r>
+          </a:p>
+          <a:p>
+            <a:pPr algn="just"/>
+            <a:r>
+              <a:rPr lang="en-US" sz="1400" noProof="0" dirty="0"/>
+              <a:t>Are you new to KIT or would you like to learn more about the campus? Then you're exactly right here! Our mobile web application </a:t>
+            </a:r>
+            <a:r>
+              <a:rPr lang="en-US" sz="1400" b="1" noProof="0" dirty="0"/>
+              <a:t>Explore KIT Campus</a:t>
+            </a:r>
+            <a:r>
+              <a:rPr lang="en-US" sz="1400" noProof="0" dirty="0"/>
+              <a:t> allows you to get an overview of the campus. Whether it's dining options, buildings, monuments, or parking, find out more about them in our app and use the routing function to get to your destination.</a:t>
+            </a:r>
+          </a:p>
+        </p:txBody>
+      </p:sp>
+      <p:sp>
+        <p:nvSpPr>
+          <p:cNvPr id="16" name="Textfeld 15">
+            <a:extLst>
+              <a:ext uri="{FF2B5EF4-FFF2-40B4-BE49-F238E27FC236}">
+                <a16:creationId xmlns:a16="http://schemas.microsoft.com/office/drawing/2014/main" id="{93CE7B81-765F-C24C-A011-A5FDF1749845}"/>
+              </a:ext>
+            </a:extLst>
+          </p:cNvPr>
+          <p:cNvSpPr txBox="1"/>
+          <p:nvPr/>
+        </p:nvSpPr>
+        <p:spPr>
+          <a:xfrm>
+            <a:off x="2286522" y="3223468"/>
+            <a:ext cx="2506012" cy="4139595"/>
+          </a:xfrm>
+          <a:prstGeom prst="rect">
+            <a:avLst/>
+          </a:prstGeom>
+          <a:noFill/>
+        </p:spPr>
+        <p:txBody>
+          <a:bodyPr wrap="square" rtlCol="0">
+            <a:spAutoFit/>
+          </a:bodyPr>
+          <a:lstStyle/>
+          <a:p>
+            <a:r>
+              <a:rPr lang="en-US" sz="2400" b="1" noProof="0" dirty="0">
+                <a:solidFill>
+                  <a:srgbClr val="009682"/>
+                </a:solidFill>
+              </a:rPr>
+              <a:t>Features</a:t>
+            </a:r>
+          </a:p>
+          <a:p>
+            <a:r>
+              <a:rPr lang="en-US" sz="1400" b="1" noProof="0" dirty="0"/>
+              <a:t>Interactive Campus Map</a:t>
+            </a:r>
+          </a:p>
+          <a:p>
+            <a:pPr>
+              <a:spcAft>
+                <a:spcPts val="600"/>
+              </a:spcAft>
+            </a:pPr>
+            <a:r>
+              <a:rPr lang="en-US" sz="1400" noProof="0" dirty="0"/>
+              <a:t>Find all key places: buildings, parks, dining halls, and more.</a:t>
+            </a:r>
+            <a:endParaRPr lang="en-US" sz="1400" b="1" noProof="0" dirty="0"/>
+          </a:p>
+          <a:p>
+            <a:r>
+              <a:rPr lang="en-US" sz="1400" b="1" noProof="0" dirty="0"/>
+              <a:t>Detailed Information</a:t>
+            </a:r>
+          </a:p>
+          <a:p>
+            <a:pPr>
+              <a:spcAft>
+                <a:spcPts val="600"/>
+              </a:spcAft>
+            </a:pPr>
+            <a:r>
+              <a:rPr lang="en-US" sz="1400" noProof="0" dirty="0"/>
+              <a:t>Need specific information about a room, café, or building? Check the detailed information box.</a:t>
+            </a:r>
+          </a:p>
+          <a:p>
+            <a:r>
+              <a:rPr lang="en-US" sz="1400" b="1" noProof="0" dirty="0"/>
+              <a:t>Routing</a:t>
+            </a:r>
+          </a:p>
+          <a:p>
+            <a:pPr>
+              <a:spcAft>
+                <a:spcPts val="600"/>
+              </a:spcAft>
+            </a:pPr>
+            <a:r>
+              <a:rPr lang="en-US" sz="1400" noProof="0" dirty="0"/>
+              <a:t>Want to go somewhere? Plan your route across campus.</a:t>
+            </a:r>
+          </a:p>
+          <a:p>
+            <a:r>
+              <a:rPr lang="en-US" sz="1400" b="1" noProof="0" dirty="0"/>
+              <a:t>Weather</a:t>
+            </a:r>
+          </a:p>
+          <a:p>
+            <a:r>
+              <a:rPr lang="en-US" sz="1400" noProof="0" dirty="0"/>
+              <a:t>Planning an outdoor learning session? Check the current weather with the integrated weather panel.</a:t>
+            </a:r>
+          </a:p>
+        </p:txBody>
+      </p:sp>
+      <p:sp>
+        <p:nvSpPr>
+          <p:cNvPr id="17" name="Textfeld 16">
+            <a:extLst>
+              <a:ext uri="{FF2B5EF4-FFF2-40B4-BE49-F238E27FC236}">
+                <a16:creationId xmlns:a16="http://schemas.microsoft.com/office/drawing/2014/main" id="{5A1C9DCC-095F-F709-F266-C19A9B0C0637}"/>
+              </a:ext>
+            </a:extLst>
+          </p:cNvPr>
+          <p:cNvSpPr txBox="1"/>
+          <p:nvPr/>
+        </p:nvSpPr>
+        <p:spPr>
+          <a:xfrm>
+            <a:off x="143510" y="7340410"/>
+            <a:ext cx="1706880" cy="1323439"/>
+          </a:xfrm>
+          <a:prstGeom prst="rect">
+            <a:avLst/>
+          </a:prstGeom>
+          <a:noFill/>
+        </p:spPr>
+        <p:txBody>
+          <a:bodyPr wrap="square" rtlCol="0">
+            <a:spAutoFit/>
+          </a:bodyPr>
+          <a:lstStyle/>
+          <a:p>
+            <a:r>
+              <a:rPr lang="en-US" sz="2400" b="1" noProof="0" dirty="0">
+                <a:solidFill>
+                  <a:srgbClr val="009682"/>
+                </a:solidFill>
+              </a:rPr>
+              <a:t>Try it now!</a:t>
+            </a:r>
+          </a:p>
+          <a:p>
+            <a:r>
+              <a:rPr lang="en-US" sz="1400" dirty="0"/>
+              <a:t>Available as browser preview. https://20korvin01.github.io/www/</a:t>
+            </a:r>
+            <a:endParaRPr lang="en-US" sz="1400" noProof="0" dirty="0"/>
+          </a:p>
+        </p:txBody>
+      </p:sp>
+      <p:sp>
+        <p:nvSpPr>
+          <p:cNvPr id="20" name="Textfeld 19">
+            <a:extLst>
+              <a:ext uri="{FF2B5EF4-FFF2-40B4-BE49-F238E27FC236}">
+                <a16:creationId xmlns:a16="http://schemas.microsoft.com/office/drawing/2014/main" id="{97F88839-2ADE-4BD8-4731-A624875F1147}"/>
+              </a:ext>
+            </a:extLst>
+          </p:cNvPr>
+          <p:cNvSpPr txBox="1"/>
+          <p:nvPr/>
+        </p:nvSpPr>
+        <p:spPr>
+          <a:xfrm>
+            <a:off x="1756700" y="7331342"/>
+            <a:ext cx="3035834" cy="1969770"/>
+          </a:xfrm>
+          <a:prstGeom prst="rect">
+            <a:avLst/>
+          </a:prstGeom>
+          <a:noFill/>
+        </p:spPr>
+        <p:txBody>
+          <a:bodyPr wrap="square" rtlCol="0">
+            <a:spAutoFit/>
+          </a:bodyPr>
+          <a:lstStyle/>
+          <a:p>
+            <a:r>
+              <a:rPr lang="en-US" sz="2400" noProof="0" dirty="0"/>
+              <a:t>  </a:t>
+            </a:r>
+            <a:r>
+              <a:rPr lang="en-US" sz="2400" b="1" noProof="0" dirty="0">
+                <a:solidFill>
+                  <a:srgbClr val="009682"/>
+                </a:solidFill>
+              </a:rPr>
+              <a:t>Why use the app?</a:t>
+            </a:r>
+          </a:p>
+          <a:p>
+            <a:pPr marL="285750" indent="-285750">
+              <a:buSzPct val="100000"/>
+              <a:buFont typeface="Wingdings" panose="05000000000000000000" pitchFamily="2" charset="2"/>
+              <a:buChar char="Ø"/>
+            </a:pPr>
+            <a:r>
+              <a:rPr lang="en-US" sz="1400" dirty="0"/>
+              <a:t>Orientation for </a:t>
+            </a:r>
+            <a:r>
+              <a:rPr lang="en-US" sz="1400" u="sng" dirty="0"/>
+              <a:t>first-year students</a:t>
+            </a:r>
+          </a:p>
+          <a:p>
+            <a:pPr marL="285750" indent="-285750">
+              <a:buSzPct val="100000"/>
+              <a:buFont typeface="Wingdings" panose="05000000000000000000" pitchFamily="2" charset="2"/>
+              <a:buChar char="Ø"/>
+            </a:pPr>
+            <a:r>
+              <a:rPr lang="en-US" sz="1400" noProof="0" dirty="0"/>
+              <a:t>Packed with information for </a:t>
+            </a:r>
+            <a:r>
+              <a:rPr lang="en-US" sz="1400" u="sng" noProof="0" dirty="0"/>
+              <a:t>visitors and guests</a:t>
+            </a:r>
+          </a:p>
+          <a:p>
+            <a:pPr marL="285750" indent="-285750">
+              <a:buSzPct val="100000"/>
+              <a:buFont typeface="Wingdings" panose="05000000000000000000" pitchFamily="2" charset="2"/>
+              <a:buChar char="Ø"/>
+            </a:pPr>
+            <a:r>
+              <a:rPr lang="en-US" sz="1400" dirty="0"/>
+              <a:t>Optimize routes on campus for </a:t>
+            </a:r>
+            <a:r>
+              <a:rPr lang="en-US" sz="1400" u="sng" dirty="0"/>
+              <a:t>students, staff and researchers</a:t>
+            </a:r>
+          </a:p>
+          <a:p>
+            <a:pPr marL="285750" indent="-285750">
+              <a:buSzPct val="100000"/>
+              <a:buFont typeface="Wingdings" panose="05000000000000000000" pitchFamily="2" charset="2"/>
+              <a:buChar char="Ø"/>
+            </a:pPr>
+            <a:r>
+              <a:rPr lang="en-US" sz="1400" noProof="0" dirty="0"/>
+              <a:t>For </a:t>
+            </a:r>
+            <a:r>
+              <a:rPr lang="en-US" sz="1400" u="sng" noProof="0" dirty="0"/>
+              <a:t>You</a:t>
+            </a:r>
+            <a:r>
+              <a:rPr lang="en-US" sz="1400" noProof="0" dirty="0"/>
+              <a:t> to explore KIT!</a:t>
+            </a:r>
+          </a:p>
+        </p:txBody>
+      </p:sp>
+      <p:pic>
+        <p:nvPicPr>
+          <p:cNvPr id="26" name="Grafik 25">
+            <a:extLst>
+              <a:ext uri="{FF2B5EF4-FFF2-40B4-BE49-F238E27FC236}">
+                <a16:creationId xmlns:a16="http://schemas.microsoft.com/office/drawing/2014/main" id="{56EE92A4-10C9-9FCC-3F49-5CD6EE737241}"/>
+              </a:ext>
+            </a:extLst>
+          </p:cNvPr>
+          <p:cNvPicPr>
+            <a:picLocks noChangeAspect="1"/>
+          </p:cNvPicPr>
+          <p:nvPr/>
+        </p:nvPicPr>
+        <p:blipFill>
+          <a:blip r:embed="rId3">
+            <a:extLst>
+              <a:ext uri="{28A0092B-C50C-407E-A947-70E740481C1C}">
+                <a14:useLocalDpi xmlns:a14="http://schemas.microsoft.com/office/drawing/2010/main" val="0"/>
+              </a:ext>
+            </a:extLst>
+          </a:blip>
+          <a:stretch>
+            <a:fillRect/>
+          </a:stretch>
+        </p:blipFill>
+        <p:spPr>
+          <a:xfrm>
+            <a:off x="2149043" y="3348738"/>
+            <a:ext cx="228600" cy="228600"/>
+          </a:xfrm>
+          <a:prstGeom prst="rect">
+            <a:avLst/>
+          </a:prstGeom>
+        </p:spPr>
+      </p:pic>
+      <p:pic>
+        <p:nvPicPr>
+          <p:cNvPr id="28" name="Grafik 27">
+            <a:extLst>
+              <a:ext uri="{FF2B5EF4-FFF2-40B4-BE49-F238E27FC236}">
+                <a16:creationId xmlns:a16="http://schemas.microsoft.com/office/drawing/2014/main" id="{14DF68F5-29B9-4707-99FC-8C5FCC64DABA}"/>
+              </a:ext>
+            </a:extLst>
+          </p:cNvPr>
+          <p:cNvPicPr>
+            <a:picLocks noChangeAspect="1"/>
+          </p:cNvPicPr>
+          <p:nvPr/>
+        </p:nvPicPr>
+        <p:blipFill>
+          <a:blip r:embed="rId4">
+            <a:extLst>
+              <a:ext uri="{28A0092B-C50C-407E-A947-70E740481C1C}">
+                <a14:useLocalDpi xmlns:a14="http://schemas.microsoft.com/office/drawing/2010/main" val="0"/>
+              </a:ext>
+            </a:extLst>
+          </a:blip>
+          <a:stretch>
+            <a:fillRect/>
+          </a:stretch>
+        </p:blipFill>
+        <p:spPr>
+          <a:xfrm>
+            <a:off x="2149043" y="3607482"/>
+            <a:ext cx="228600" cy="228600"/>
+          </a:xfrm>
+          <a:prstGeom prst="rect">
+            <a:avLst/>
+          </a:prstGeom>
+        </p:spPr>
+      </p:pic>
+      <p:pic>
+        <p:nvPicPr>
+          <p:cNvPr id="30" name="Grafik 29">
+            <a:extLst>
+              <a:ext uri="{FF2B5EF4-FFF2-40B4-BE49-F238E27FC236}">
+                <a16:creationId xmlns:a16="http://schemas.microsoft.com/office/drawing/2014/main" id="{1C564834-49BF-70FD-B40A-F4DB2653E205}"/>
+              </a:ext>
+            </a:extLst>
+          </p:cNvPr>
+          <p:cNvPicPr>
+            <a:picLocks noChangeAspect="1"/>
+          </p:cNvPicPr>
+          <p:nvPr/>
+        </p:nvPicPr>
+        <p:blipFill>
+          <a:blip r:embed="rId5">
+            <a:extLst>
+              <a:ext uri="{28A0092B-C50C-407E-A947-70E740481C1C}">
+                <a14:useLocalDpi xmlns:a14="http://schemas.microsoft.com/office/drawing/2010/main" val="0"/>
+              </a:ext>
+            </a:extLst>
+          </a:blip>
+          <a:stretch>
+            <a:fillRect/>
+          </a:stretch>
+        </p:blipFill>
+        <p:spPr>
+          <a:xfrm>
+            <a:off x="2149043" y="6186233"/>
+            <a:ext cx="228600" cy="228600"/>
+          </a:xfrm>
+          <a:prstGeom prst="rect">
+            <a:avLst/>
+          </a:prstGeom>
+        </p:spPr>
+      </p:pic>
+      <p:pic>
+        <p:nvPicPr>
+          <p:cNvPr id="32" name="Grafik 31">
+            <a:extLst>
+              <a:ext uri="{FF2B5EF4-FFF2-40B4-BE49-F238E27FC236}">
+                <a16:creationId xmlns:a16="http://schemas.microsoft.com/office/drawing/2014/main" id="{99ED45A3-D7D8-DEC6-D86C-12C9C3D1A0BF}"/>
+              </a:ext>
+            </a:extLst>
+          </p:cNvPr>
+          <p:cNvPicPr>
+            <a:picLocks noChangeAspect="1"/>
+          </p:cNvPicPr>
+          <p:nvPr/>
+        </p:nvPicPr>
+        <p:blipFill>
+          <a:blip r:embed="rId6">
+            <a:extLst>
+              <a:ext uri="{28A0092B-C50C-407E-A947-70E740481C1C}">
+                <a14:useLocalDpi xmlns:a14="http://schemas.microsoft.com/office/drawing/2010/main" val="0"/>
+              </a:ext>
+            </a:extLst>
+          </a:blip>
+          <a:stretch>
+            <a:fillRect/>
+          </a:stretch>
+        </p:blipFill>
+        <p:spPr>
+          <a:xfrm>
+            <a:off x="2149043" y="5501052"/>
+            <a:ext cx="228600" cy="228600"/>
+          </a:xfrm>
+          <a:prstGeom prst="rect">
+            <a:avLst/>
+          </a:prstGeom>
+        </p:spPr>
+      </p:pic>
+      <p:pic>
+        <p:nvPicPr>
+          <p:cNvPr id="34" name="Grafik 33">
+            <a:extLst>
+              <a:ext uri="{FF2B5EF4-FFF2-40B4-BE49-F238E27FC236}">
+                <a16:creationId xmlns:a16="http://schemas.microsoft.com/office/drawing/2014/main" id="{EBF45964-F787-E160-F4C5-E67F16FE49E5}"/>
+              </a:ext>
+            </a:extLst>
+          </p:cNvPr>
+          <p:cNvPicPr>
+            <a:picLocks noChangeAspect="1"/>
+          </p:cNvPicPr>
+          <p:nvPr/>
+        </p:nvPicPr>
+        <p:blipFill>
+          <a:blip r:embed="rId7">
+            <a:extLst>
+              <a:ext uri="{28A0092B-C50C-407E-A947-70E740481C1C}">
+                <a14:useLocalDpi xmlns:a14="http://schemas.microsoft.com/office/drawing/2010/main" val="0"/>
+              </a:ext>
+            </a:extLst>
+          </a:blip>
+          <a:stretch>
+            <a:fillRect/>
+          </a:stretch>
+        </p:blipFill>
+        <p:spPr>
+          <a:xfrm>
+            <a:off x="2149043" y="4343463"/>
+            <a:ext cx="228600" cy="228600"/>
+          </a:xfrm>
+          <a:prstGeom prst="rect">
+            <a:avLst/>
+          </a:prstGeom>
+        </p:spPr>
+      </p:pic>
+      <p:pic>
+        <p:nvPicPr>
+          <p:cNvPr id="3" name="Grafik 2" descr="Ein Bild, das Text, Karte, Handy, Screenshot enthält.&#10;&#10;KI-generierte Inhalte können fehlerhaft sein.">
+            <a:extLst>
+              <a:ext uri="{FF2B5EF4-FFF2-40B4-BE49-F238E27FC236}">
+                <a16:creationId xmlns:a16="http://schemas.microsoft.com/office/drawing/2014/main" id="{567BB894-E936-872B-3EA3-E77F917E07A8}"/>
+              </a:ext>
+            </a:extLst>
+          </p:cNvPr>
+          <p:cNvPicPr>
+            <a:picLocks noChangeAspect="1"/>
+          </p:cNvPicPr>
+          <p:nvPr/>
+        </p:nvPicPr>
+        <p:blipFill>
+          <a:blip r:embed="rId8" cstate="print">
+            <a:extLst>
+              <a:ext uri="{28A0092B-C50C-407E-A947-70E740481C1C}">
+                <a14:useLocalDpi xmlns:a14="http://schemas.microsoft.com/office/drawing/2010/main" val="0"/>
+              </a:ext>
+            </a:extLst>
+          </a:blip>
+          <a:stretch>
+            <a:fillRect/>
+          </a:stretch>
+        </p:blipFill>
+        <p:spPr>
+          <a:xfrm>
+            <a:off x="4792534" y="1253454"/>
+            <a:ext cx="1958340" cy="3916679"/>
+          </a:xfrm>
+          <a:prstGeom prst="roundRect">
+            <a:avLst/>
+          </a:prstGeom>
+        </p:spPr>
+      </p:pic>
+      <p:pic>
+        <p:nvPicPr>
+          <p:cNvPr id="10" name="Grafik 9" descr="Ein Bild, das Text, Handy, Screenshot, Kommunikationsgerät enthält.&#10;&#10;KI-generierte Inhalte können fehlerhaft sein.">
+            <a:extLst>
+              <a:ext uri="{FF2B5EF4-FFF2-40B4-BE49-F238E27FC236}">
+                <a16:creationId xmlns:a16="http://schemas.microsoft.com/office/drawing/2014/main" id="{A5A6909F-6023-3EB6-9304-BE260A72CEF7}"/>
+              </a:ext>
+            </a:extLst>
+          </p:cNvPr>
+          <p:cNvPicPr>
+            <a:picLocks noChangeAspect="1"/>
+          </p:cNvPicPr>
+          <p:nvPr/>
+        </p:nvPicPr>
+        <p:blipFill>
+          <a:blip r:embed="rId9" cstate="print">
+            <a:extLst>
+              <a:ext uri="{28A0092B-C50C-407E-A947-70E740481C1C}">
+                <a14:useLocalDpi xmlns:a14="http://schemas.microsoft.com/office/drawing/2010/main" val="0"/>
+              </a:ext>
+            </a:extLst>
+          </a:blip>
+          <a:stretch>
+            <a:fillRect/>
+          </a:stretch>
+        </p:blipFill>
+        <p:spPr>
+          <a:xfrm>
+            <a:off x="121964" y="3336299"/>
+            <a:ext cx="1958340" cy="3916679"/>
+          </a:xfrm>
+          <a:prstGeom prst="roundRect">
+            <a:avLst/>
+          </a:prstGeom>
+        </p:spPr>
+      </p:pic>
+      <p:pic>
+        <p:nvPicPr>
+          <p:cNvPr id="18" name="Grafik 17" descr="Ein Bild, das Text, Handy, Screenshot, Kommunikationsgerät enthält.&#10;&#10;KI-generierte Inhalte können fehlerhaft sein.">
+            <a:extLst>
+              <a:ext uri="{FF2B5EF4-FFF2-40B4-BE49-F238E27FC236}">
+                <a16:creationId xmlns:a16="http://schemas.microsoft.com/office/drawing/2014/main" id="{DCE99546-2FBA-DCBA-71A2-E4240B68BC75}"/>
+              </a:ext>
+            </a:extLst>
+          </p:cNvPr>
+          <p:cNvPicPr>
+            <a:picLocks noChangeAspect="1"/>
+          </p:cNvPicPr>
+          <p:nvPr/>
+        </p:nvPicPr>
+        <p:blipFill>
+          <a:blip r:embed="rId10" cstate="print">
+            <a:extLst>
+              <a:ext uri="{28A0092B-C50C-407E-A947-70E740481C1C}">
+                <a14:useLocalDpi xmlns:a14="http://schemas.microsoft.com/office/drawing/2010/main" val="0"/>
+              </a:ext>
+            </a:extLst>
+          </a:blip>
+          <a:stretch>
+            <a:fillRect/>
+          </a:stretch>
+        </p:blipFill>
+        <p:spPr>
+          <a:xfrm>
+            <a:off x="4777696" y="5305825"/>
+            <a:ext cx="1958340" cy="3916679"/>
+          </a:xfrm>
+          <a:prstGeom prst="roundRect">
+            <a:avLst/>
+          </a:prstGeom>
+        </p:spPr>
+      </p:pic>
+      <p:pic>
+        <p:nvPicPr>
+          <p:cNvPr id="21" name="Grafik 20" descr="Ein Bild, das Muster, Design, Grafiken, Quadrat enthält.&#10;&#10;KI-generierte Inhalte können fehlerhaft sein.">
+            <a:extLst>
+              <a:ext uri="{FF2B5EF4-FFF2-40B4-BE49-F238E27FC236}">
+                <a16:creationId xmlns:a16="http://schemas.microsoft.com/office/drawing/2014/main" id="{A3750688-E62E-0F62-C23F-25E68AFA23B0}"/>
+              </a:ext>
+            </a:extLst>
+          </p:cNvPr>
+          <p:cNvPicPr>
+            <a:picLocks noChangeAspect="1"/>
+          </p:cNvPicPr>
+          <p:nvPr/>
+        </p:nvPicPr>
+        <p:blipFill>
+          <a:blip r:embed="rId11" cstate="print">
+            <a:extLst>
+              <a:ext uri="{28A0092B-C50C-407E-A947-70E740481C1C}">
+                <a14:useLocalDpi xmlns:a14="http://schemas.microsoft.com/office/drawing/2010/main" val="0"/>
+              </a:ext>
+            </a:extLst>
+          </a:blip>
+          <a:stretch>
+            <a:fillRect/>
+          </a:stretch>
+        </p:blipFill>
+        <p:spPr>
+          <a:xfrm>
+            <a:off x="444500" y="8666788"/>
+            <a:ext cx="1096896" cy="1096896"/>
+          </a:xfrm>
+          <a:prstGeom prst="rect">
+            <a:avLst/>
+          </a:prstGeom>
+        </p:spPr>
+      </p:pic>
+    </p:spTree>
+    <p:extLst>
+      <p:ext uri="{BB962C8B-B14F-4D97-AF65-F5344CB8AC3E}">
+        <p14:creationId xmlns:p14="http://schemas.microsoft.com/office/powerpoint/2010/main" val="2282797444"/>
+      </p:ext>
+    </p:extLst>
+  </p:cSld>
+  <p:clrMapOvr>
+    <a:masterClrMapping/>
+  </p:clrMapOvr>
+</p:sld>
+</file>
+
+<file path=ppt/slides/slide3.xml><?xml version="1.0" encoding="utf-8"?>
+<p:sld xmlns:a="http://schemas.openxmlformats.org/drawingml/2006/main" xmlns:r="http://schemas.openxmlformats.org/officeDocument/2006/relationships" xmlns:p="http://schemas.openxmlformats.org/presentationml/2006/main">
+  <p:cSld>
+    <p:spTree>
+      <p:nvGrpSpPr>
+        <p:cNvPr id="1" name="">
+          <a:extLst>
+            <a:ext uri="{FF2B5EF4-FFF2-40B4-BE49-F238E27FC236}">
+              <a16:creationId xmlns:a16="http://schemas.microsoft.com/office/drawing/2014/main" id="{4DDFC70B-2306-5DA0-64F2-C3B159D55C9E}"/>
+            </a:ext>
+          </a:extLst>
+        </p:cNvPr>
+        <p:cNvGrpSpPr/>
+        <p:nvPr/>
+      </p:nvGrpSpPr>
+      <p:grpSpPr>
+        <a:xfrm>
+          <a:off x="0" y="0"/>
+          <a:ext cx="0" cy="0"/>
+          <a:chOff x="0" y="0"/>
+          <a:chExt cx="0" cy="0"/>
+        </a:xfrm>
+      </p:grpSpPr>
+      <p:sp>
+        <p:nvSpPr>
+          <p:cNvPr id="4" name="Textfeld 3">
+            <a:extLst>
+              <a:ext uri="{FF2B5EF4-FFF2-40B4-BE49-F238E27FC236}">
+                <a16:creationId xmlns:a16="http://schemas.microsoft.com/office/drawing/2014/main" id="{DB6957E2-3241-0E0D-6C5B-7E768821E6EE}"/>
+              </a:ext>
+            </a:extLst>
+          </p:cNvPr>
+          <p:cNvSpPr txBox="1"/>
+          <p:nvPr/>
+        </p:nvSpPr>
+        <p:spPr>
+          <a:xfrm>
+            <a:off x="154934" y="152400"/>
+            <a:ext cx="4433906" cy="1015663"/>
+          </a:xfrm>
+          <a:prstGeom prst="rect">
+            <a:avLst/>
+          </a:prstGeom>
+          <a:noFill/>
+        </p:spPr>
+        <p:txBody>
+          <a:bodyPr wrap="none" rtlCol="0">
+            <a:spAutoFit/>
+          </a:bodyPr>
+          <a:lstStyle/>
+          <a:p>
+            <a:r>
+              <a:rPr lang="en-US" sz="3600" noProof="0" dirty="0"/>
+              <a:t>Explore KIT Campus</a:t>
+            </a:r>
+          </a:p>
+          <a:p>
+            <a:r>
+              <a:rPr lang="en-US" sz="2400" noProof="0" dirty="0"/>
+              <a:t>Discover, Navigate, Enjoy.</a:t>
+            </a:r>
+          </a:p>
+        </p:txBody>
+      </p:sp>
+      <p:pic>
+        <p:nvPicPr>
+          <p:cNvPr id="7" name="Grafik 6" descr="Ein Bild, das Text, Screenshot, Diagramm, Zahl enthält.&#10;&#10;KI-generierte Inhalte können fehlerhaft sein.">
+            <a:extLst>
+              <a:ext uri="{FF2B5EF4-FFF2-40B4-BE49-F238E27FC236}">
+                <a16:creationId xmlns:a16="http://schemas.microsoft.com/office/drawing/2014/main" id="{2E970563-B33C-324C-4E10-E8DF9CD46823}"/>
+              </a:ext>
+            </a:extLst>
+          </p:cNvPr>
+          <p:cNvPicPr>
+            <a:picLocks noChangeAspect="1"/>
+          </p:cNvPicPr>
+          <p:nvPr/>
+        </p:nvPicPr>
+        <p:blipFill>
+          <a:blip r:embed="rId2" cstate="print">
+            <a:extLst>
+              <a:ext uri="{28A0092B-C50C-407E-A947-70E740481C1C}">
+                <a14:useLocalDpi xmlns:a14="http://schemas.microsoft.com/office/drawing/2010/main" val="0"/>
+              </a:ext>
+            </a:extLst>
+          </a:blip>
+          <a:stretch>
+            <a:fillRect/>
+          </a:stretch>
+        </p:blipFill>
+        <p:spPr>
+          <a:xfrm>
+            <a:off x="4898789" y="1353363"/>
+            <a:ext cx="1806810" cy="4015134"/>
+          </a:xfrm>
+          <a:prstGeom prst="rect">
+            <a:avLst/>
+          </a:prstGeom>
+        </p:spPr>
+      </p:pic>
+      <p:pic>
+        <p:nvPicPr>
+          <p:cNvPr id="9" name="Grafik 8" descr="Ein Bild, das Text, Screenshot, Karte, Software enthält.&#10;&#10;KI-generierte Inhalte können fehlerhaft sein.">
+            <a:extLst>
+              <a:ext uri="{FF2B5EF4-FFF2-40B4-BE49-F238E27FC236}">
+                <a16:creationId xmlns:a16="http://schemas.microsoft.com/office/drawing/2014/main" id="{9D373B73-F9D7-13D0-A9A5-1B8FA4DD4876}"/>
+              </a:ext>
+            </a:extLst>
+          </p:cNvPr>
+          <p:cNvPicPr>
+            <a:picLocks noChangeAspect="1"/>
+          </p:cNvPicPr>
+          <p:nvPr/>
+        </p:nvPicPr>
+        <p:blipFill>
+          <a:blip r:embed="rId3" cstate="print">
+            <a:extLst>
+              <a:ext uri="{28A0092B-C50C-407E-A947-70E740481C1C}">
+                <a14:useLocalDpi xmlns:a14="http://schemas.microsoft.com/office/drawing/2010/main" val="0"/>
+              </a:ext>
+            </a:extLst>
+          </a:blip>
+          <a:stretch>
+            <a:fillRect/>
+          </a:stretch>
+        </p:blipFill>
+        <p:spPr>
+          <a:xfrm>
+            <a:off x="152399" y="3309103"/>
+            <a:ext cx="1806811" cy="4015135"/>
+          </a:xfrm>
+          <a:prstGeom prst="rect">
+            <a:avLst/>
+          </a:prstGeom>
+        </p:spPr>
+      </p:pic>
+      <p:pic>
+        <p:nvPicPr>
+          <p:cNvPr id="11" name="Grafik 10" descr="Ein Bild, das Text, Software, Computersymbol, Betriebssystem enthält.&#10;&#10;KI-generierte Inhalte können fehlerhaft sein.">
+            <a:extLst>
+              <a:ext uri="{FF2B5EF4-FFF2-40B4-BE49-F238E27FC236}">
+                <a16:creationId xmlns:a16="http://schemas.microsoft.com/office/drawing/2014/main" id="{9F4706B4-9C3F-9390-5E74-B9C1176FFBF8}"/>
+              </a:ext>
+            </a:extLst>
+          </p:cNvPr>
+          <p:cNvPicPr>
+            <a:picLocks noChangeAspect="1"/>
+          </p:cNvPicPr>
+          <p:nvPr/>
+        </p:nvPicPr>
+        <p:blipFill>
+          <a:blip r:embed="rId4" cstate="print">
+            <a:extLst>
+              <a:ext uri="{28A0092B-C50C-407E-A947-70E740481C1C}">
+                <a14:useLocalDpi xmlns:a14="http://schemas.microsoft.com/office/drawing/2010/main" val="0"/>
+              </a:ext>
+            </a:extLst>
+          </a:blip>
+          <a:stretch>
+            <a:fillRect/>
+          </a:stretch>
+        </p:blipFill>
+        <p:spPr>
+          <a:xfrm>
+            <a:off x="4898788" y="5738464"/>
+            <a:ext cx="1806811" cy="4015135"/>
+          </a:xfrm>
+          <a:prstGeom prst="rect">
+            <a:avLst/>
+          </a:prstGeom>
+        </p:spPr>
+      </p:pic>
+      <p:sp>
+        <p:nvSpPr>
+          <p:cNvPr id="12" name="Textfeld 11">
+            <a:extLst>
+              <a:ext uri="{FF2B5EF4-FFF2-40B4-BE49-F238E27FC236}">
+                <a16:creationId xmlns:a16="http://schemas.microsoft.com/office/drawing/2014/main" id="{197E6693-8FD7-A5C0-55B3-3A223D21C9A1}"/>
+              </a:ext>
+            </a:extLst>
+          </p:cNvPr>
+          <p:cNvSpPr txBox="1"/>
+          <p:nvPr/>
+        </p:nvSpPr>
+        <p:spPr>
+          <a:xfrm>
+            <a:off x="152400" y="9379010"/>
+            <a:ext cx="4434227" cy="430887"/>
+          </a:xfrm>
+          <a:prstGeom prst="rect">
+            <a:avLst/>
+          </a:prstGeom>
+          <a:noFill/>
+        </p:spPr>
+        <p:txBody>
+          <a:bodyPr wrap="none" rtlCol="0">
+            <a:spAutoFit/>
+          </a:bodyPr>
+          <a:lstStyle/>
+          <a:p>
+            <a:r>
+              <a:rPr lang="en-US" sz="1100" noProof="0" dirty="0"/>
+              <a:t>Korvin Brecht – Jasmin </a:t>
+            </a:r>
+            <a:r>
+              <a:rPr lang="en-US" sz="1100" noProof="0" dirty="0" err="1"/>
+              <a:t>Jährling</a:t>
+            </a:r>
+            <a:r>
+              <a:rPr lang="en-US" sz="1100" noProof="0" dirty="0"/>
+              <a:t> – Elisabeth Kral – Merlin Pillich</a:t>
+            </a:r>
+          </a:p>
+          <a:p>
+            <a:r>
+              <a:rPr lang="en-US" sz="1100" noProof="0" dirty="0"/>
+              <a:t>Mobile GIS – Summer Semester 2025 – Dr.-Ing. Paul Vincent Kuper</a:t>
+            </a:r>
+          </a:p>
+        </p:txBody>
+      </p:sp>
+      <p:pic>
+        <p:nvPicPr>
+          <p:cNvPr id="14" name="Grafik 13" descr="Ein Bild, das Grafiken, Screenshot, Grafikdesign, Farbigkeit enthält.&#10;&#10;KI-generierte Inhalte können fehlerhaft sein.">
+            <a:extLst>
+              <a:ext uri="{FF2B5EF4-FFF2-40B4-BE49-F238E27FC236}">
+                <a16:creationId xmlns:a16="http://schemas.microsoft.com/office/drawing/2014/main" id="{7F51C50B-C138-59A5-7B17-DD6D0501C5DF}"/>
+              </a:ext>
+            </a:extLst>
+          </p:cNvPr>
+          <p:cNvPicPr>
+            <a:picLocks noChangeAspect="1"/>
+          </p:cNvPicPr>
+          <p:nvPr/>
+        </p:nvPicPr>
+        <p:blipFill>
+          <a:blip r:embed="rId5" cstate="print">
+            <a:extLst>
+              <a:ext uri="{28A0092B-C50C-407E-A947-70E740481C1C}">
+                <a14:useLocalDpi xmlns:a14="http://schemas.microsoft.com/office/drawing/2010/main" val="0"/>
+              </a:ext>
+            </a:extLst>
+          </a:blip>
+          <a:stretch>
+            <a:fillRect/>
+          </a:stretch>
+        </p:blipFill>
+        <p:spPr>
+          <a:xfrm>
+            <a:off x="5043606" y="152399"/>
+            <a:ext cx="1661994" cy="830997"/>
+          </a:xfrm>
+          <a:prstGeom prst="rect">
+            <a:avLst/>
+          </a:prstGeom>
+        </p:spPr>
+      </p:pic>
+      <p:sp>
+        <p:nvSpPr>
+          <p:cNvPr id="15" name="Textfeld 14">
+            <a:extLst>
+              <a:ext uri="{FF2B5EF4-FFF2-40B4-BE49-F238E27FC236}">
+                <a16:creationId xmlns:a16="http://schemas.microsoft.com/office/drawing/2014/main" id="{9B0D4CED-3206-BF2F-DBEB-06CB9F859E43}"/>
+              </a:ext>
+            </a:extLst>
+          </p:cNvPr>
+          <p:cNvSpPr txBox="1"/>
+          <p:nvPr/>
+        </p:nvSpPr>
+        <p:spPr>
+          <a:xfrm>
+            <a:off x="152400" y="1253698"/>
+            <a:ext cx="4549140" cy="1969770"/>
+          </a:xfrm>
+          <a:prstGeom prst="rect">
+            <a:avLst/>
+          </a:prstGeom>
+          <a:noFill/>
+        </p:spPr>
+        <p:txBody>
+          <a:bodyPr wrap="square" rtlCol="0">
+            <a:spAutoFit/>
+          </a:bodyPr>
+          <a:lstStyle/>
+          <a:p>
+            <a:r>
+              <a:rPr lang="en-US" sz="2400" b="1" noProof="0" dirty="0">
+                <a:solidFill>
+                  <a:srgbClr val="009682"/>
+                </a:solidFill>
+              </a:rPr>
+              <a:t>What is it?</a:t>
+            </a:r>
+          </a:p>
+          <a:p>
+            <a:pPr algn="just"/>
+            <a:r>
+              <a:rPr lang="en-US" sz="1400" noProof="0" dirty="0"/>
+              <a:t>Are you new to KIT or would you like to learn more about the campus? Then you're exactly right here! Our mobile web application </a:t>
+            </a:r>
+            <a:r>
+              <a:rPr lang="en-US" sz="1400" b="1" noProof="0" dirty="0"/>
+              <a:t>Explore KIT Campus</a:t>
+            </a:r>
+            <a:r>
+              <a:rPr lang="en-US" sz="1400" noProof="0" dirty="0"/>
+              <a:t> allows you to get an overview of the campus. Whether it's dining options, buildings, monuments, or parking, find out more about them in our app and use the routing function to get to your destination.</a:t>
+            </a:r>
+          </a:p>
+        </p:txBody>
+      </p:sp>
+      <p:sp>
+        <p:nvSpPr>
+          <p:cNvPr id="16" name="Textfeld 15">
+            <a:extLst>
+              <a:ext uri="{FF2B5EF4-FFF2-40B4-BE49-F238E27FC236}">
+                <a16:creationId xmlns:a16="http://schemas.microsoft.com/office/drawing/2014/main" id="{65B11C1A-D1CB-EAB4-9822-B0E064FB473B}"/>
+              </a:ext>
+            </a:extLst>
+          </p:cNvPr>
+          <p:cNvSpPr txBox="1"/>
+          <p:nvPr/>
+        </p:nvSpPr>
+        <p:spPr>
+          <a:xfrm>
+            <a:off x="2262677" y="3223468"/>
+            <a:ext cx="2629953" cy="4139595"/>
+          </a:xfrm>
+          <a:prstGeom prst="rect">
+            <a:avLst/>
+          </a:prstGeom>
+          <a:noFill/>
+        </p:spPr>
+        <p:txBody>
+          <a:bodyPr wrap="square" rtlCol="0">
+            <a:spAutoFit/>
+          </a:bodyPr>
+          <a:lstStyle/>
+          <a:p>
+            <a:r>
+              <a:rPr lang="en-US" sz="2400" b="1" noProof="0" dirty="0">
+                <a:solidFill>
+                  <a:srgbClr val="009682"/>
+                </a:solidFill>
+              </a:rPr>
+              <a:t>Features</a:t>
+            </a:r>
+          </a:p>
+          <a:p>
+            <a:r>
+              <a:rPr lang="en-US" sz="1400" b="1" noProof="0" dirty="0"/>
+              <a:t>Interactive Campus Map</a:t>
+            </a:r>
+          </a:p>
+          <a:p>
+            <a:pPr>
+              <a:spcAft>
+                <a:spcPts val="600"/>
+              </a:spcAft>
+            </a:pPr>
+            <a:r>
+              <a:rPr lang="en-US" sz="1400" noProof="0" dirty="0"/>
+              <a:t>Find all key places – buildings, parks, dining halls, and more.</a:t>
+            </a:r>
+            <a:endParaRPr lang="en-US" sz="1400" b="1" noProof="0" dirty="0"/>
+          </a:p>
+          <a:p>
+            <a:r>
+              <a:rPr lang="en-US" sz="1400" b="1" noProof="0" dirty="0"/>
+              <a:t>Detailed Information</a:t>
+            </a:r>
+          </a:p>
+          <a:p>
+            <a:pPr>
+              <a:spcAft>
+                <a:spcPts val="600"/>
+              </a:spcAft>
+            </a:pPr>
+            <a:r>
+              <a:rPr lang="en-US" sz="1400" noProof="0" dirty="0"/>
+              <a:t>Need specific information about a room, café, or building? Check the detailed information box.</a:t>
+            </a:r>
+          </a:p>
+          <a:p>
+            <a:r>
+              <a:rPr lang="en-US" sz="1400" b="1" noProof="0" dirty="0"/>
+              <a:t>Routing</a:t>
+            </a:r>
+          </a:p>
+          <a:p>
+            <a:pPr>
+              <a:spcAft>
+                <a:spcPts val="600"/>
+              </a:spcAft>
+            </a:pPr>
+            <a:r>
+              <a:rPr lang="en-US" sz="1400" noProof="0" dirty="0"/>
+              <a:t>Want to go somewhere? Plan your route across campus.</a:t>
+            </a:r>
+          </a:p>
+          <a:p>
+            <a:r>
+              <a:rPr lang="en-US" sz="1400" b="1" noProof="0" dirty="0"/>
+              <a:t>Weather</a:t>
+            </a:r>
+          </a:p>
+          <a:p>
+            <a:r>
+              <a:rPr lang="en-US" sz="1400" noProof="0" dirty="0"/>
+              <a:t>Planning an outdoor learning session? Check the current weather with the integrated weather panel.</a:t>
+            </a:r>
+          </a:p>
+        </p:txBody>
+      </p:sp>
+      <p:sp>
+        <p:nvSpPr>
+          <p:cNvPr id="17" name="Textfeld 16">
+            <a:extLst>
+              <a:ext uri="{FF2B5EF4-FFF2-40B4-BE49-F238E27FC236}">
+                <a16:creationId xmlns:a16="http://schemas.microsoft.com/office/drawing/2014/main" id="{A7360B2B-B757-ADC8-4943-DE3530E2F805}"/>
+              </a:ext>
+            </a:extLst>
+          </p:cNvPr>
+          <p:cNvSpPr txBox="1"/>
+          <p:nvPr/>
+        </p:nvSpPr>
+        <p:spPr>
+          <a:xfrm>
+            <a:off x="152400" y="7409873"/>
+            <a:ext cx="1706880" cy="892552"/>
+          </a:xfrm>
+          <a:prstGeom prst="rect">
+            <a:avLst/>
+          </a:prstGeom>
+          <a:noFill/>
+        </p:spPr>
+        <p:txBody>
+          <a:bodyPr wrap="square" rtlCol="0">
+            <a:spAutoFit/>
+          </a:bodyPr>
+          <a:lstStyle/>
+          <a:p>
+            <a:r>
+              <a:rPr lang="en-US" sz="2400" b="1" noProof="0" dirty="0">
+                <a:solidFill>
+                  <a:srgbClr val="009682"/>
+                </a:solidFill>
+              </a:rPr>
+              <a:t>Try it now!</a:t>
+            </a:r>
+          </a:p>
+          <a:p>
+            <a:r>
+              <a:rPr lang="en-US" sz="1400" noProof="0" dirty="0"/>
+              <a:t>https://github.com/20korvin01/www/</a:t>
+            </a:r>
+          </a:p>
+        </p:txBody>
+      </p:sp>
+      <p:sp>
+        <p:nvSpPr>
+          <p:cNvPr id="20" name="Textfeld 19">
+            <a:extLst>
+              <a:ext uri="{FF2B5EF4-FFF2-40B4-BE49-F238E27FC236}">
+                <a16:creationId xmlns:a16="http://schemas.microsoft.com/office/drawing/2014/main" id="{16E06594-E514-ED20-85E8-BF1379C22DA3}"/>
+              </a:ext>
+            </a:extLst>
+          </p:cNvPr>
+          <p:cNvSpPr txBox="1"/>
+          <p:nvPr/>
+        </p:nvSpPr>
+        <p:spPr>
+          <a:xfrm>
+            <a:off x="1859280" y="7409873"/>
+            <a:ext cx="3033350" cy="1969770"/>
+          </a:xfrm>
+          <a:prstGeom prst="rect">
+            <a:avLst/>
+          </a:prstGeom>
+          <a:noFill/>
+        </p:spPr>
+        <p:txBody>
+          <a:bodyPr wrap="square" rtlCol="0">
+            <a:spAutoFit/>
+          </a:bodyPr>
+          <a:lstStyle/>
+          <a:p>
+            <a:r>
+              <a:rPr lang="en-US" sz="2400" noProof="0" dirty="0"/>
+              <a:t>  </a:t>
+            </a:r>
+            <a:r>
+              <a:rPr lang="en-US" sz="2400" b="1" noProof="0" dirty="0">
+                <a:solidFill>
+                  <a:srgbClr val="009682"/>
+                </a:solidFill>
+              </a:rPr>
+              <a:t>Why use the app?</a:t>
+            </a:r>
+          </a:p>
+          <a:p>
+            <a:pPr marL="285750" indent="-285750">
+              <a:buSzPct val="100000"/>
+              <a:buFont typeface="Wingdings" panose="05000000000000000000" pitchFamily="2" charset="2"/>
+              <a:buChar char="Ø"/>
+            </a:pPr>
+            <a:r>
+              <a:rPr lang="en-US" sz="1400" dirty="0"/>
+              <a:t>Orientation for </a:t>
+            </a:r>
+            <a:r>
+              <a:rPr lang="en-US" sz="1400" u="sng" dirty="0"/>
+              <a:t>first-year students</a:t>
+            </a:r>
+          </a:p>
+          <a:p>
+            <a:pPr marL="285750" indent="-285750">
+              <a:buSzPct val="100000"/>
+              <a:buFont typeface="Wingdings" panose="05000000000000000000" pitchFamily="2" charset="2"/>
+              <a:buChar char="Ø"/>
+            </a:pPr>
+            <a:r>
+              <a:rPr lang="en-US" sz="1400" noProof="0" dirty="0"/>
+              <a:t>Packed with information for </a:t>
+            </a:r>
+            <a:r>
+              <a:rPr lang="en-US" sz="1400" u="sng" noProof="0" dirty="0"/>
+              <a:t>visitors and guests</a:t>
+            </a:r>
+          </a:p>
+          <a:p>
+            <a:pPr marL="285750" indent="-285750">
+              <a:buSzPct val="100000"/>
+              <a:buFont typeface="Wingdings" panose="05000000000000000000" pitchFamily="2" charset="2"/>
+              <a:buChar char="Ø"/>
+            </a:pPr>
+            <a:r>
+              <a:rPr lang="en-US" sz="1400" dirty="0"/>
+              <a:t>Optimize routes on campus for </a:t>
+            </a:r>
+            <a:r>
+              <a:rPr lang="en-US" sz="1400" u="sng" dirty="0"/>
+              <a:t>students, staff and researchers</a:t>
+            </a:r>
+          </a:p>
+          <a:p>
+            <a:pPr marL="285750" indent="-285750">
+              <a:buSzPct val="100000"/>
+              <a:buFont typeface="Wingdings" panose="05000000000000000000" pitchFamily="2" charset="2"/>
+              <a:buChar char="Ø"/>
+            </a:pPr>
+            <a:r>
+              <a:rPr lang="en-US" sz="1400" u="sng" noProof="0" dirty="0"/>
+              <a:t>Anyone</a:t>
+            </a:r>
+            <a:r>
+              <a:rPr lang="en-US" sz="1400" noProof="0" dirty="0"/>
+              <a:t> curious about KIT!</a:t>
+            </a:r>
+          </a:p>
+        </p:txBody>
+      </p:sp>
+      <p:pic>
+        <p:nvPicPr>
+          <p:cNvPr id="22" name="Grafik 21" descr="Ein Bild, das Muster, Design, Quadrat, Pixel enthält.&#10;&#10;KI-generierte Inhalte können fehlerhaft sein.">
+            <a:extLst>
+              <a:ext uri="{FF2B5EF4-FFF2-40B4-BE49-F238E27FC236}">
+                <a16:creationId xmlns:a16="http://schemas.microsoft.com/office/drawing/2014/main" id="{EEFD1571-70C5-6EA7-29A7-ED38DE206883}"/>
+              </a:ext>
+            </a:extLst>
+          </p:cNvPr>
+          <p:cNvPicPr>
+            <a:picLocks noChangeAspect="1"/>
+          </p:cNvPicPr>
+          <p:nvPr/>
+        </p:nvPicPr>
+        <p:blipFill>
+          <a:blip r:embed="rId6" cstate="print">
+            <a:extLst>
+              <a:ext uri="{28A0092B-C50C-407E-A947-70E740481C1C}">
+                <a14:useLocalDpi xmlns:a14="http://schemas.microsoft.com/office/drawing/2010/main" val="0"/>
+              </a:ext>
+            </a:extLst>
+          </a:blip>
+          <a:stretch>
+            <a:fillRect/>
+          </a:stretch>
+        </p:blipFill>
+        <p:spPr>
+          <a:xfrm>
+            <a:off x="425834" y="8296815"/>
+            <a:ext cx="1088892" cy="1088892"/>
+          </a:xfrm>
+          <a:prstGeom prst="rect">
+            <a:avLst/>
+          </a:prstGeom>
+        </p:spPr>
+      </p:pic>
+      <p:pic>
+        <p:nvPicPr>
+          <p:cNvPr id="26" name="Grafik 25">
+            <a:extLst>
+              <a:ext uri="{FF2B5EF4-FFF2-40B4-BE49-F238E27FC236}">
+                <a16:creationId xmlns:a16="http://schemas.microsoft.com/office/drawing/2014/main" id="{D4092787-9296-9395-3742-23BA0C111F71}"/>
+              </a:ext>
+            </a:extLst>
+          </p:cNvPr>
+          <p:cNvPicPr>
+            <a:picLocks noChangeAspect="1"/>
+          </p:cNvPicPr>
+          <p:nvPr/>
+        </p:nvPicPr>
+        <p:blipFill>
+          <a:blip r:embed="rId7">
+            <a:extLst>
+              <a:ext uri="{28A0092B-C50C-407E-A947-70E740481C1C}">
+                <a14:useLocalDpi xmlns:a14="http://schemas.microsoft.com/office/drawing/2010/main" val="0"/>
+              </a:ext>
+            </a:extLst>
+          </a:blip>
+          <a:stretch>
+            <a:fillRect/>
+          </a:stretch>
+        </p:blipFill>
+        <p:spPr>
+          <a:xfrm>
+            <a:off x="2110943" y="3348738"/>
+            <a:ext cx="228600" cy="228600"/>
+          </a:xfrm>
+          <a:prstGeom prst="rect">
+            <a:avLst/>
+          </a:prstGeom>
+        </p:spPr>
+      </p:pic>
+      <p:pic>
+        <p:nvPicPr>
+          <p:cNvPr id="28" name="Grafik 27">
+            <a:extLst>
+              <a:ext uri="{FF2B5EF4-FFF2-40B4-BE49-F238E27FC236}">
+                <a16:creationId xmlns:a16="http://schemas.microsoft.com/office/drawing/2014/main" id="{8066229F-21C2-E8E4-B865-89DB9EF93027}"/>
+              </a:ext>
+            </a:extLst>
+          </p:cNvPr>
+          <p:cNvPicPr>
+            <a:picLocks noChangeAspect="1"/>
+          </p:cNvPicPr>
+          <p:nvPr/>
+        </p:nvPicPr>
+        <p:blipFill>
+          <a:blip r:embed="rId8">
+            <a:extLst>
+              <a:ext uri="{28A0092B-C50C-407E-A947-70E740481C1C}">
+                <a14:useLocalDpi xmlns:a14="http://schemas.microsoft.com/office/drawing/2010/main" val="0"/>
+              </a:ext>
+            </a:extLst>
+          </a:blip>
+          <a:stretch>
+            <a:fillRect/>
+          </a:stretch>
+        </p:blipFill>
+        <p:spPr>
+          <a:xfrm>
+            <a:off x="2110943" y="3607482"/>
+            <a:ext cx="228600" cy="228600"/>
+          </a:xfrm>
+          <a:prstGeom prst="rect">
+            <a:avLst/>
+          </a:prstGeom>
+        </p:spPr>
+      </p:pic>
+      <p:pic>
+        <p:nvPicPr>
+          <p:cNvPr id="30" name="Grafik 29">
+            <a:extLst>
+              <a:ext uri="{FF2B5EF4-FFF2-40B4-BE49-F238E27FC236}">
+                <a16:creationId xmlns:a16="http://schemas.microsoft.com/office/drawing/2014/main" id="{08A3CF0F-BB5A-36DF-B9E8-A20E77DFEF1B}"/>
+              </a:ext>
+            </a:extLst>
+          </p:cNvPr>
+          <p:cNvPicPr>
+            <a:picLocks noChangeAspect="1"/>
+          </p:cNvPicPr>
+          <p:nvPr/>
+        </p:nvPicPr>
+        <p:blipFill>
+          <a:blip r:embed="rId9">
+            <a:extLst>
+              <a:ext uri="{28A0092B-C50C-407E-A947-70E740481C1C}">
+                <a14:useLocalDpi xmlns:a14="http://schemas.microsoft.com/office/drawing/2010/main" val="0"/>
+              </a:ext>
+            </a:extLst>
+          </a:blip>
+          <a:stretch>
+            <a:fillRect/>
+          </a:stretch>
+        </p:blipFill>
+        <p:spPr>
+          <a:xfrm>
+            <a:off x="2110943" y="6656133"/>
+            <a:ext cx="228600" cy="228600"/>
+          </a:xfrm>
+          <a:prstGeom prst="rect">
+            <a:avLst/>
+          </a:prstGeom>
+        </p:spPr>
+      </p:pic>
+      <p:pic>
+        <p:nvPicPr>
+          <p:cNvPr id="32" name="Grafik 31">
+            <a:extLst>
+              <a:ext uri="{FF2B5EF4-FFF2-40B4-BE49-F238E27FC236}">
+                <a16:creationId xmlns:a16="http://schemas.microsoft.com/office/drawing/2014/main" id="{E008ECD8-6573-7E37-9ED7-B35BAD26DF11}"/>
+              </a:ext>
+            </a:extLst>
+          </p:cNvPr>
+          <p:cNvPicPr>
+            <a:picLocks noChangeAspect="1"/>
+          </p:cNvPicPr>
+          <p:nvPr/>
+        </p:nvPicPr>
+        <p:blipFill>
+          <a:blip r:embed="rId10">
+            <a:extLst>
+              <a:ext uri="{28A0092B-C50C-407E-A947-70E740481C1C}">
+                <a14:useLocalDpi xmlns:a14="http://schemas.microsoft.com/office/drawing/2010/main" val="0"/>
+              </a:ext>
+            </a:extLst>
+          </a:blip>
+          <a:stretch>
+            <a:fillRect/>
+          </a:stretch>
+        </p:blipFill>
+        <p:spPr>
+          <a:xfrm>
+            <a:off x="2110943" y="5691552"/>
+            <a:ext cx="228600" cy="228600"/>
+          </a:xfrm>
+          <a:prstGeom prst="rect">
+            <a:avLst/>
+          </a:prstGeom>
+        </p:spPr>
+      </p:pic>
+      <p:pic>
+        <p:nvPicPr>
+          <p:cNvPr id="34" name="Grafik 33">
+            <a:extLst>
+              <a:ext uri="{FF2B5EF4-FFF2-40B4-BE49-F238E27FC236}">
+                <a16:creationId xmlns:a16="http://schemas.microsoft.com/office/drawing/2014/main" id="{5966CA7F-A31B-A494-E11F-4CBA4E341347}"/>
+              </a:ext>
+            </a:extLst>
+          </p:cNvPr>
+          <p:cNvPicPr>
+            <a:picLocks noChangeAspect="1"/>
+          </p:cNvPicPr>
+          <p:nvPr/>
+        </p:nvPicPr>
+        <p:blipFill>
+          <a:blip r:embed="rId11">
+            <a:extLst>
+              <a:ext uri="{28A0092B-C50C-407E-A947-70E740481C1C}">
+                <a14:useLocalDpi xmlns:a14="http://schemas.microsoft.com/office/drawing/2010/main" val="0"/>
+              </a:ext>
+            </a:extLst>
+          </a:blip>
+          <a:stretch>
+            <a:fillRect/>
+          </a:stretch>
+        </p:blipFill>
+        <p:spPr>
+          <a:xfrm>
+            <a:off x="2110943" y="4572063"/>
+            <a:ext cx="228600" cy="228600"/>
+          </a:xfrm>
+          <a:prstGeom prst="rect">
+            <a:avLst/>
+          </a:prstGeom>
+        </p:spPr>
+      </p:pic>
+    </p:spTree>
+    <p:extLst>
+      <p:ext uri="{BB962C8B-B14F-4D97-AF65-F5344CB8AC3E}">
+        <p14:creationId xmlns:p14="http://schemas.microsoft.com/office/powerpoint/2010/main" val="360856496"/>
+      </p:ext>
+    </p:extLst>
+  </p:cSld>
+  <p:clrMapOvr>
+    <a:masterClrMapping/>
+  </p:clrMapOvr>
+</p:sld>
+</file>
+
+<file path=ppt/slides/slide4.xml><?xml version="1.0" encoding="utf-8"?>
 <p:sld xmlns:a="http://schemas.openxmlformats.org/drawingml/2006/main" xmlns:r="http://schemas.openxmlformats.org/officeDocument/2006/relationships" xmlns:p="http://schemas.openxmlformats.org/presentationml/2006/main">
   <p:cSld>
     <p:spTree>

</xml_diff>